<commit_message>
Add admin user account navigation
</commit_message>
<xml_diff>
--- a/output/slides/ooad-checkpoint-draft/OOAD_Checkpoint_ZH_Draft.pptx
+++ b/output/slides/ooad-checkpoint-draft/OOAD_Checkpoint_ZH_Draft.pptx
@@ -605,7 +605,7 @@
 </file>
 
 <file path=ppt/notesSlides/notesSlide11.xml><?xml version="1.0" encoding="utf-8"?>
-<p:notes xmlns:p="http://schemas.openxmlformats.org/presentationml/2006/main">
+<p:notes xmlns:a="http://schemas.openxmlformats.org/drawingml/2006/main" xmlns:p="http://schemas.openxmlformats.org/presentationml/2006/main">
   <p:cSld>
     <p:spTree>
       <p:nvGrpSpPr>
@@ -614,13 +614,13 @@
         <p:nvPr/>
       </p:nvGrpSpPr>
       <p:grpSpPr>
-        <a:xfrm xmlns:a="http://schemas.openxmlformats.org/drawingml/2006/main"/>
+        <a:xfrm/>
       </p:grpSpPr>
       <p:sp>
         <p:nvSpPr>
           <p:cNvPr id="2" name="Slide Image Placeholder 1"/>
           <p:cNvSpPr>
-            <a:spLocks xmlns:a="http://schemas.openxmlformats.org/drawingml/2006/main" noGrp="1"/>
+            <a:spLocks noGrp="1"/>
           </p:cNvSpPr>
           <p:nvPr>
             <p:ph type="sldImg" idx="0"/>
@@ -632,7 +632,7 @@
         <p:nvSpPr>
           <p:cNvPr id="3" name="Notes Placeholder 2"/>
           <p:cNvSpPr>
-            <a:spLocks xmlns:a="http://schemas.openxmlformats.org/drawingml/2006/main" noGrp="1"/>
+            <a:spLocks noGrp="1"/>
           </p:cNvSpPr>
           <p:nvPr>
             <p:ph type="body" idx="1"/>
@@ -640,11 +640,11 @@
         </p:nvSpPr>
         <p:spPr/>
         <p:txBody>
-          <a:bodyPr xmlns:a="http://schemas.openxmlformats.org/drawingml/2006/main"/>
-          <a:lstStyle xmlns:a="http://schemas.openxmlformats.org/drawingml/2006/main"/>
-          <a:p xmlns:a="http://schemas.openxmlformats.org/drawingml/2006/main">
-            <a:r>
-              <a:t>說明 Strategy Pattern 不只是理論，而是用在警示規則與回測策略，解決未來擴充不同規則與策略的問題。</a:t>
+          <a:bodyPr/>
+          <a:lstStyle/>
+          <a:p>
+            <a:r>
+              <a:t>說明 Strategy Pattern 在回測領域的角色。BacktestEngine 不知道每種策略的演算法細節，只透過 TradingStrategy 共同介面取得 warmup period 與交易訊號，因此 MovingAverageCross、RSI 或突破策略都能套用同一個回測流程。</a:t>
             </a:r>
           </a:p>
         </p:txBody>
@@ -653,7 +653,7 @@
         <p:nvSpPr>
           <p:cNvPr id="4" name="Slide Number Placeholder 3"/>
           <p:cNvSpPr>
-            <a:spLocks xmlns:a="http://schemas.openxmlformats.org/drawingml/2006/main" noGrp="1"/>
+            <a:spLocks noGrp="1"/>
           </p:cNvSpPr>
           <p:nvPr>
             <p:ph type="sldNum" idx="5"/>
@@ -661,21 +661,21 @@
         </p:nvSpPr>
         <p:spPr/>
         <p:txBody>
-          <a:bodyPr xmlns:a="http://schemas.openxmlformats.org/drawingml/2006/main"/>
-          <a:lstStyle xmlns:a="http://schemas.openxmlformats.org/drawingml/2006/main"/>
-          <a:p xmlns:a="http://schemas.openxmlformats.org/drawingml/2006/main"/>
+          <a:bodyPr/>
+          <a:lstStyle/>
+          <a:p/>
         </p:txBody>
       </p:sp>
     </p:spTree>
   </p:cSld>
   <p:clrMapOvr>
-    <a:masterClrMapping xmlns:a="http://schemas.openxmlformats.org/drawingml/2006/main"/>
+    <a:masterClrMapping/>
   </p:clrMapOvr>
 </p:notes>
 </file>
 
 <file path=ppt/notesSlides/notesSlide12.xml><?xml version="1.0" encoding="utf-8"?>
-<p:notes xmlns:p="http://schemas.openxmlformats.org/presentationml/2006/main">
+<p:notes xmlns:a="http://schemas.openxmlformats.org/drawingml/2006/main" xmlns:p="http://schemas.openxmlformats.org/presentationml/2006/main">
   <p:cSld>
     <p:spTree>
       <p:nvGrpSpPr>
@@ -684,13 +684,13 @@
         <p:nvPr/>
       </p:nvGrpSpPr>
       <p:grpSpPr>
-        <a:xfrm xmlns:a="http://schemas.openxmlformats.org/drawingml/2006/main"/>
+        <a:xfrm/>
       </p:grpSpPr>
       <p:sp>
         <p:nvSpPr>
           <p:cNvPr id="2" name="Slide Image Placeholder 1"/>
           <p:cNvSpPr>
-            <a:spLocks xmlns:a="http://schemas.openxmlformats.org/drawingml/2006/main" noGrp="1"/>
+            <a:spLocks noGrp="1"/>
           </p:cNvSpPr>
           <p:nvPr>
             <p:ph type="sldImg" idx="0"/>
@@ -702,7 +702,7 @@
         <p:nvSpPr>
           <p:cNvPr id="3" name="Notes Placeholder 2"/>
           <p:cNvSpPr>
-            <a:spLocks xmlns:a="http://schemas.openxmlformats.org/drawingml/2006/main" noGrp="1"/>
+            <a:spLocks noGrp="1"/>
           </p:cNvSpPr>
           <p:nvPr>
             <p:ph type="body" idx="1"/>
@@ -710,11 +710,11 @@
         </p:nvSpPr>
         <p:spPr/>
         <p:txBody>
-          <a:bodyPr xmlns:a="http://schemas.openxmlformats.org/drawingml/2006/main"/>
-          <a:lstStyle xmlns:a="http://schemas.openxmlformats.org/drawingml/2006/main"/>
-          <a:p xmlns:a="http://schemas.openxmlformats.org/drawingml/2006/main">
-            <a:r>
-              <a:t>說明 Factory Pattern 負責把資料庫儲存的設定轉成正確的 AlertRule 物件，讓 API 不需要知道每個具體類別。</a:t>
+          <a:bodyPr/>
+          <a:lstStyle/>
+          <a:p>
+            <a:r>
+              <a:t>說明 Template Method Pattern 與 Strategy 的差異。AlertRule 的 buildNotification 固定通知產生流程，但會呼叫 getConditionLabel，讓 PriceAboveAlertRule、PriceBelowAlertRule 等子類別補上不同條件文字與觸發判斷。</a:t>
             </a:r>
           </a:p>
         </p:txBody>
@@ -723,7 +723,7 @@
         <p:nvSpPr>
           <p:cNvPr id="4" name="Slide Number Placeholder 3"/>
           <p:cNvSpPr>
-            <a:spLocks xmlns:a="http://schemas.openxmlformats.org/drawingml/2006/main" noGrp="1"/>
+            <a:spLocks noGrp="1"/>
           </p:cNvSpPr>
           <p:nvPr>
             <p:ph type="sldNum" idx="5"/>
@@ -731,15 +731,15 @@
         </p:nvSpPr>
         <p:spPr/>
         <p:txBody>
-          <a:bodyPr xmlns:a="http://schemas.openxmlformats.org/drawingml/2006/main"/>
-          <a:lstStyle xmlns:a="http://schemas.openxmlformats.org/drawingml/2006/main"/>
-          <a:p xmlns:a="http://schemas.openxmlformats.org/drawingml/2006/main"/>
+          <a:bodyPr/>
+          <a:lstStyle/>
+          <a:p/>
         </p:txBody>
       </p:sp>
     </p:spTree>
   </p:cSld>
   <p:clrMapOvr>
-    <a:masterClrMapping xmlns:a="http://schemas.openxmlformats.org/drawingml/2006/main"/>
+    <a:masterClrMapping/>
   </p:clrMapOvr>
 </p:notes>
 </file>
@@ -7205,11 +7205,11 @@
 </file>
 
 <file path=ppt/slides/slide11.xml><?xml version="1.0" encoding="utf-8"?>
-<p:sld xmlns:p="http://schemas.openxmlformats.org/presentationml/2006/main">
+<p:sld xmlns:a="http://schemas.openxmlformats.org/drawingml/2006/main" xmlns:ns2="http://schemas.microsoft.com/office/drawing/2014/main" xmlns:ns3="http://schemas.microsoft.com/office/powerpoint/2010/main" xmlns:p="http://schemas.openxmlformats.org/presentationml/2006/main">
   <p:cSld>
     <p:bg>
       <p:bgPr>
-        <a:solidFill xmlns:a="http://schemas.openxmlformats.org/drawingml/2006/main">
+        <a:solidFill>
           <a:srgbClr val="F5F1E8"/>
         </a:solidFill>
       </p:bgPr>
@@ -7221,34 +7221,34 @@
         <p:nvPr/>
       </p:nvGrpSpPr>
       <p:grpSpPr>
-        <a:xfrm xmlns:a="http://schemas.openxmlformats.org/drawingml/2006/main"/>
+        <a:xfrm/>
       </p:grpSpPr>
       <p:sp>
         <p:nvSpPr>
           <p:cNvPr id="1" name="">
-            <a:extLst xmlns:a="http://schemas.openxmlformats.org/drawingml/2006/main">
-              <a:ext uri="{FF2B5EF4-FFF2-40B4-BE49-F238E27FC236}">
-                <a16:creationId xmlns:a16="http://schemas.microsoft.com/office/drawing/2014/main" id="{ACF3C1D5-F998-4845-9597-D06CE45C4D38}"/>
-              </a:ext>
-            </a:extLst>
-          </p:cNvPr>
-          <p:cNvSpPr>
-            <a:spLocks xmlns:a="http://schemas.openxmlformats.org/drawingml/2006/main" noGrp="1"/>
-          </p:cNvSpPr>
-          <p:nvPr/>
-        </p:nvSpPr>
-        <p:spPr>
-          <a:xfrm xmlns:a="http://schemas.openxmlformats.org/drawingml/2006/main" rot="0">
+            <a:extLst>
+              <a:ext uri="{FF2B5EF4-FFF2-40B4-BE49-F238E27FC236}">
+                <ns2:creationId id="{ACF3C1D5-F998-4845-9597-D06CE45C4D38}"/>
+              </a:ext>
+            </a:extLst>
+          </p:cNvPr>
+          <p:cNvSpPr>
+            <a:spLocks noGrp="1"/>
+          </p:cNvSpPr>
+          <p:nvPr/>
+        </p:nvSpPr>
+        <p:spPr>
+          <a:xfrm rot="0">
             <a:off x="9620250" y="-857250"/>
             <a:ext cx="3429000" cy="3429000"/>
           </a:xfrm>
-          <a:prstGeom xmlns:a="http://schemas.openxmlformats.org/drawingml/2006/main" prst="ellipse">
-            <a:avLst/>
-          </a:prstGeom>
-          <a:solidFill xmlns:a="http://schemas.openxmlformats.org/drawingml/2006/main">
+          <a:prstGeom prst="ellipse">
+            <a:avLst/>
+          </a:prstGeom>
+          <a:solidFill>
             <a:srgbClr val="DFF5EC"/>
           </a:solidFill>
-          <a:ln xmlns:a="http://schemas.openxmlformats.org/drawingml/2006/main" w="0">
+          <a:ln w="0">
             <a:solidFill>
               <a:srgbClr val="000000">
                 <a:alpha val="0"/>
@@ -7261,29 +7261,29 @@
       <p:sp>
         <p:nvSpPr>
           <p:cNvPr id="2" name="">
-            <a:extLst xmlns:a="http://schemas.openxmlformats.org/drawingml/2006/main">
-              <a:ext uri="{FF2B5EF4-FFF2-40B4-BE49-F238E27FC236}">
-                <a16:creationId xmlns:a16="http://schemas.microsoft.com/office/drawing/2014/main" id="{B7405F5E-6072-4ECC-B7C5-A34D9A1B908E}"/>
-              </a:ext>
-            </a:extLst>
-          </p:cNvPr>
-          <p:cNvSpPr>
-            <a:spLocks xmlns:a="http://schemas.openxmlformats.org/drawingml/2006/main" noGrp="1"/>
-          </p:cNvSpPr>
-          <p:nvPr/>
-        </p:nvSpPr>
-        <p:spPr>
-          <a:xfrm xmlns:a="http://schemas.openxmlformats.org/drawingml/2006/main" rot="0">
+            <a:extLst>
+              <a:ext uri="{FF2B5EF4-FFF2-40B4-BE49-F238E27FC236}">
+                <ns2:creationId id="{B7405F5E-6072-4ECC-B7C5-A34D9A1B908E}"/>
+              </a:ext>
+            </a:extLst>
+          </p:cNvPr>
+          <p:cNvSpPr>
+            <a:spLocks noGrp="1"/>
+          </p:cNvSpPr>
+          <p:nvPr/>
+        </p:nvSpPr>
+        <p:spPr>
+          <a:xfrm rot="0">
             <a:off x="-857250" y="5334000"/>
             <a:ext cx="2286000" cy="2286000"/>
           </a:xfrm>
-          <a:prstGeom xmlns:a="http://schemas.openxmlformats.org/drawingml/2006/main" prst="ellipse">
-            <a:avLst/>
-          </a:prstGeom>
-          <a:solidFill xmlns:a="http://schemas.openxmlformats.org/drawingml/2006/main">
+          <a:prstGeom prst="ellipse">
+            <a:avLst/>
+          </a:prstGeom>
+          <a:solidFill>
             <a:srgbClr val="FAEFD9"/>
           </a:solidFill>
-          <a:ln xmlns:a="http://schemas.openxmlformats.org/drawingml/2006/main" w="0">
+          <a:ln w="0">
             <a:solidFill>
               <a:srgbClr val="000000">
                 <a:alpha val="0"/>
@@ -7296,31 +7296,31 @@
       <p:sp>
         <p:nvSpPr>
           <p:cNvPr id="3" name="">
-            <a:extLst xmlns:a="http://schemas.openxmlformats.org/drawingml/2006/main">
-              <a:ext uri="{FF2B5EF4-FFF2-40B4-BE49-F238E27FC236}">
-                <a16:creationId xmlns:a16="http://schemas.microsoft.com/office/drawing/2014/main" id="{9E762F36-AA0D-4544-9968-8AD0964AF411}"/>
-              </a:ext>
-            </a:extLst>
-          </p:cNvPr>
-          <p:cNvSpPr>
-            <a:spLocks xmlns:a="http://schemas.openxmlformats.org/drawingml/2006/main" noGrp="1"/>
-          </p:cNvSpPr>
-          <p:nvPr/>
-        </p:nvSpPr>
-        <p:spPr>
-          <a:xfrm xmlns:a="http://schemas.openxmlformats.org/drawingml/2006/main" rot="0">
+            <a:extLst>
+              <a:ext uri="{FF2B5EF4-FFF2-40B4-BE49-F238E27FC236}">
+                <ns2:creationId id="{9E762F36-AA0D-4544-9968-8AD0964AF411}"/>
+              </a:ext>
+            </a:extLst>
+          </p:cNvPr>
+          <p:cNvSpPr>
+            <a:spLocks noGrp="1"/>
+          </p:cNvSpPr>
+          <p:nvPr/>
+        </p:nvSpPr>
+        <p:spPr>
+          <a:xfrm rot="0">
             <a:off x="609600" y="266700"/>
             <a:ext cx="3429000" cy="171450"/>
           </a:xfrm>
-          <a:prstGeom xmlns:a="http://schemas.openxmlformats.org/drawingml/2006/main" prst="rect">
-            <a:avLst/>
-          </a:prstGeom>
-          <a:solidFill xmlns:a="http://schemas.openxmlformats.org/drawingml/2006/main">
+          <a:prstGeom prst="rect">
+            <a:avLst/>
+          </a:prstGeom>
+          <a:solidFill>
             <a:srgbClr val="000000">
               <a:alpha val="0"/>
             </a:srgbClr>
           </a:solidFill>
-          <a:ln xmlns:a="http://schemas.openxmlformats.org/drawingml/2006/main" w="0">
+          <a:ln w="0">
             <a:solidFill>
               <a:srgbClr val="000000">
                 <a:alpha val="0"/>
@@ -7330,9 +7330,9 @@
           </a:ln>
         </p:spPr>
         <p:txBody>
-          <a:bodyPr xmlns:a="http://schemas.openxmlformats.org/drawingml/2006/main" lIns="0" tIns="0" rIns="0" bIns="0" anchor="t"/>
-          <a:lstStyle xmlns:a="http://schemas.openxmlformats.org/drawingml/2006/main"/>
-          <a:p xmlns:a="http://schemas.openxmlformats.org/drawingml/2006/main">
+          <a:bodyPr lIns="0" tIns="0" rIns="0" bIns="0" anchor="t"/>
+          <a:lstStyle/>
+          <a:p>
             <a:pPr algn="l">
               <a:defRPr sz="825" b="1">
                 <a:solidFill>
@@ -7354,31 +7354,31 @@
       <p:sp>
         <p:nvSpPr>
           <p:cNvPr id="4" name="">
-            <a:extLst xmlns:a="http://schemas.openxmlformats.org/drawingml/2006/main">
-              <a:ext uri="{FF2B5EF4-FFF2-40B4-BE49-F238E27FC236}">
-                <a16:creationId xmlns:a16="http://schemas.microsoft.com/office/drawing/2014/main" id="{10C59D8C-7EB8-4A50-9299-45255B9479F3}"/>
-              </a:ext>
-            </a:extLst>
-          </p:cNvPr>
-          <p:cNvSpPr>
-            <a:spLocks xmlns:a="http://schemas.openxmlformats.org/drawingml/2006/main" noGrp="1"/>
-          </p:cNvSpPr>
-          <p:nvPr/>
-        </p:nvSpPr>
-        <p:spPr>
-          <a:xfrm xmlns:a="http://schemas.openxmlformats.org/drawingml/2006/main" rot="0">
+            <a:extLst>
+              <a:ext uri="{FF2B5EF4-FFF2-40B4-BE49-F238E27FC236}">
+                <ns2:creationId id="{10C59D8C-7EB8-4A50-9299-45255B9479F3}"/>
+              </a:ext>
+            </a:extLst>
+          </p:cNvPr>
+          <p:cNvSpPr>
+            <a:spLocks noGrp="1"/>
+          </p:cNvSpPr>
+          <p:nvPr/>
+        </p:nvSpPr>
+        <p:spPr>
+          <a:xfrm rot="0">
             <a:off x="11163300" y="247650"/>
             <a:ext cx="419100" cy="190500"/>
           </a:xfrm>
-          <a:prstGeom xmlns:a="http://schemas.openxmlformats.org/drawingml/2006/main" prst="rect">
-            <a:avLst/>
-          </a:prstGeom>
-          <a:solidFill xmlns:a="http://schemas.openxmlformats.org/drawingml/2006/main">
+          <a:prstGeom prst="rect">
+            <a:avLst/>
+          </a:prstGeom>
+          <a:solidFill>
             <a:srgbClr val="000000">
               <a:alpha val="0"/>
             </a:srgbClr>
           </a:solidFill>
-          <a:ln xmlns:a="http://schemas.openxmlformats.org/drawingml/2006/main" w="0">
+          <a:ln w="0">
             <a:solidFill>
               <a:srgbClr val="000000">
                 <a:alpha val="0"/>
@@ -7388,9 +7388,9 @@
           </a:ln>
         </p:spPr>
         <p:txBody>
-          <a:bodyPr xmlns:a="http://schemas.openxmlformats.org/drawingml/2006/main" lIns="0" tIns="0" rIns="0" bIns="0" anchor="t"/>
-          <a:lstStyle xmlns:a="http://schemas.openxmlformats.org/drawingml/2006/main"/>
-          <a:p xmlns:a="http://schemas.openxmlformats.org/drawingml/2006/main">
+          <a:bodyPr lIns="0" tIns="0" rIns="0" bIns="0" anchor="t"/>
+          <a:lstStyle/>
+          <a:p>
             <a:pPr algn="r">
               <a:defRPr sz="900" b="1">
                 <a:solidFill>
@@ -7412,29 +7412,29 @@
       <p:sp>
         <p:nvSpPr>
           <p:cNvPr id="5" name="">
-            <a:extLst xmlns:a="http://schemas.openxmlformats.org/drawingml/2006/main">
-              <a:ext uri="{FF2B5EF4-FFF2-40B4-BE49-F238E27FC236}">
-                <a16:creationId xmlns:a16="http://schemas.microsoft.com/office/drawing/2014/main" id="{CBE5ADFC-9BAE-4874-AFCE-2750D64B1E91}"/>
-              </a:ext>
-            </a:extLst>
-          </p:cNvPr>
-          <p:cNvSpPr>
-            <a:spLocks xmlns:a="http://schemas.openxmlformats.org/drawingml/2006/main" noGrp="1"/>
-          </p:cNvSpPr>
-          <p:nvPr/>
-        </p:nvSpPr>
-        <p:spPr>
-          <a:xfrm xmlns:a="http://schemas.openxmlformats.org/drawingml/2006/main" rot="0">
+            <a:extLst>
+              <a:ext uri="{FF2B5EF4-FFF2-40B4-BE49-F238E27FC236}">
+                <ns2:creationId id="{CBE5ADFC-9BAE-4874-AFCE-2750D64B1E91}"/>
+              </a:ext>
+            </a:extLst>
+          </p:cNvPr>
+          <p:cNvSpPr>
+            <a:spLocks noGrp="1"/>
+          </p:cNvSpPr>
+          <p:nvPr/>
+        </p:nvSpPr>
+        <p:spPr>
+          <a:xfrm rot="0">
             <a:off x="609600" y="514350"/>
             <a:ext cx="10972800" cy="19050"/>
           </a:xfrm>
-          <a:prstGeom xmlns:a="http://schemas.openxmlformats.org/drawingml/2006/main" prst="rect">
-            <a:avLst/>
-          </a:prstGeom>
-          <a:solidFill xmlns:a="http://schemas.openxmlformats.org/drawingml/2006/main">
+          <a:prstGeom prst="rect">
+            <a:avLst/>
+          </a:prstGeom>
+          <a:solidFill>
             <a:srgbClr val="23313B"/>
           </a:solidFill>
-          <a:ln xmlns:a="http://schemas.openxmlformats.org/drawingml/2006/main" w="0">
+          <a:ln w="0">
             <a:solidFill>
               <a:srgbClr val="000000">
                 <a:alpha val="0"/>
@@ -7447,31 +7447,31 @@
       <p:sp>
         <p:nvSpPr>
           <p:cNvPr id="6" name="">
-            <a:extLst xmlns:a="http://schemas.openxmlformats.org/drawingml/2006/main">
-              <a:ext uri="{FF2B5EF4-FFF2-40B4-BE49-F238E27FC236}">
-                <a16:creationId xmlns:a16="http://schemas.microsoft.com/office/drawing/2014/main" id="{F33EF3D8-62CB-4B77-A3F7-D5E2EF5F230D}"/>
-              </a:ext>
-            </a:extLst>
-          </p:cNvPr>
-          <p:cNvSpPr>
-            <a:spLocks xmlns:a="http://schemas.openxmlformats.org/drawingml/2006/main" noGrp="1"/>
-          </p:cNvSpPr>
-          <p:nvPr/>
-        </p:nvSpPr>
-        <p:spPr>
-          <a:xfrm xmlns:a="http://schemas.openxmlformats.org/drawingml/2006/main" rot="0">
+            <a:extLst>
+              <a:ext uri="{FF2B5EF4-FFF2-40B4-BE49-F238E27FC236}">
+                <ns2:creationId id="{F33EF3D8-62CB-4B77-A3F7-D5E2EF5F230D}"/>
+              </a:ext>
+            </a:extLst>
+          </p:cNvPr>
+          <p:cNvSpPr>
+            <a:spLocks noGrp="1"/>
+          </p:cNvSpPr>
+          <p:nvPr/>
+        </p:nvSpPr>
+        <p:spPr>
+          <a:xfrm rot="0">
             <a:off x="609600" y="781050"/>
             <a:ext cx="8858250" cy="514350"/>
           </a:xfrm>
-          <a:prstGeom xmlns:a="http://schemas.openxmlformats.org/drawingml/2006/main" prst="rect">
-            <a:avLst/>
-          </a:prstGeom>
-          <a:solidFill xmlns:a="http://schemas.openxmlformats.org/drawingml/2006/main">
+          <a:prstGeom prst="rect">
+            <a:avLst/>
+          </a:prstGeom>
+          <a:solidFill>
             <a:srgbClr val="000000">
               <a:alpha val="0"/>
             </a:srgbClr>
           </a:solidFill>
-          <a:ln xmlns:a="http://schemas.openxmlformats.org/drawingml/2006/main" w="0">
+          <a:ln w="0">
             <a:solidFill>
               <a:srgbClr val="000000">
                 <a:alpha val="0"/>
@@ -7481,9 +7481,9 @@
           </a:ln>
         </p:spPr>
         <p:txBody>
-          <a:bodyPr xmlns:a="http://schemas.openxmlformats.org/drawingml/2006/main" lIns="0" tIns="0" rIns="0" bIns="0" anchor="t"/>
-          <a:lstStyle xmlns:a="http://schemas.openxmlformats.org/drawingml/2006/main"/>
-          <a:p xmlns:a="http://schemas.openxmlformats.org/drawingml/2006/main">
+          <a:bodyPr lIns="0" tIns="0" rIns="0" bIns="0" anchor="t"/>
+          <a:lstStyle/>
+          <a:p>
             <a:pPr algn="l">
               <a:defRPr sz="2400" b="1">
                 <a:solidFill>
@@ -7505,31 +7505,31 @@
       <p:sp>
         <p:nvSpPr>
           <p:cNvPr id="7" name="">
-            <a:extLst xmlns:a="http://schemas.openxmlformats.org/drawingml/2006/main">
-              <a:ext uri="{FF2B5EF4-FFF2-40B4-BE49-F238E27FC236}">
-                <a16:creationId xmlns:a16="http://schemas.microsoft.com/office/drawing/2014/main" id="{557A604C-DD00-4FD7-B680-9E15706F82EF}"/>
-              </a:ext>
-            </a:extLst>
-          </p:cNvPr>
-          <p:cNvSpPr>
-            <a:spLocks xmlns:a="http://schemas.openxmlformats.org/drawingml/2006/main" noGrp="1"/>
-          </p:cNvSpPr>
-          <p:nvPr/>
-        </p:nvSpPr>
-        <p:spPr>
-          <a:xfrm xmlns:a="http://schemas.openxmlformats.org/drawingml/2006/main" rot="0">
+            <a:extLst>
+              <a:ext uri="{FF2B5EF4-FFF2-40B4-BE49-F238E27FC236}">
+                <ns2:creationId id="{557A604C-DD00-4FD7-B680-9E15706F82EF}"/>
+              </a:ext>
+            </a:extLst>
+          </p:cNvPr>
+          <p:cNvSpPr>
+            <a:spLocks noGrp="1"/>
+          </p:cNvSpPr>
+          <p:nvPr/>
+        </p:nvSpPr>
+        <p:spPr>
+          <a:xfrm rot="0">
             <a:off x="628650" y="1257300"/>
             <a:ext cx="9334500" cy="400050"/>
           </a:xfrm>
-          <a:prstGeom xmlns:a="http://schemas.openxmlformats.org/drawingml/2006/main" prst="rect">
-            <a:avLst/>
-          </a:prstGeom>
-          <a:solidFill xmlns:a="http://schemas.openxmlformats.org/drawingml/2006/main">
+          <a:prstGeom prst="rect">
+            <a:avLst/>
+          </a:prstGeom>
+          <a:solidFill>
             <a:srgbClr val="000000">
               <a:alpha val="0"/>
             </a:srgbClr>
           </a:solidFill>
-          <a:ln xmlns:a="http://schemas.openxmlformats.org/drawingml/2006/main" w="0">
+          <a:ln w="0">
             <a:solidFill>
               <a:srgbClr val="000000">
                 <a:alpha val="0"/>
@@ -7539,9 +7539,9 @@
           </a:ln>
         </p:spPr>
         <p:txBody>
-          <a:bodyPr xmlns:a="http://schemas.openxmlformats.org/drawingml/2006/main" lIns="0" tIns="0" rIns="0" bIns="0" anchor="t"/>
-          <a:lstStyle xmlns:a="http://schemas.openxmlformats.org/drawingml/2006/main"/>
-          <a:p xmlns:a="http://schemas.openxmlformats.org/drawingml/2006/main">
+          <a:bodyPr lIns="0" tIns="0" rIns="0" bIns="0" anchor="t"/>
+          <a:lstStyle/>
+          <a:p>
             <a:pPr algn="l">
               <a:defRPr sz="1200" b="0">
                 <a:solidFill>
@@ -7555,7 +7555,7 @@
                   <a:srgbClr val="4F5B66"/>
                 </a:solidFill>
               </a:rPr>
-              <a:t>說明設計意圖、實際使用位置，以及對原型的影響。</a:t>
+              <a:t>以回測策略說明：引擎固定流程，策略演算法可替換。</a:t>
             </a:r>
           </a:p>
         </p:txBody>
@@ -7563,31 +7563,31 @@
       <p:sp>
         <p:nvSpPr>
           <p:cNvPr id="8" name="">
-            <a:extLst xmlns:a="http://schemas.openxmlformats.org/drawingml/2006/main">
-              <a:ext uri="{FF2B5EF4-FFF2-40B4-BE49-F238E27FC236}">
-                <a16:creationId xmlns:a16="http://schemas.microsoft.com/office/drawing/2014/main" id="{E2D97AA9-0F5A-44C5-80E2-1E973617D2B6}"/>
-              </a:ext>
-            </a:extLst>
-          </p:cNvPr>
-          <p:cNvSpPr>
-            <a:spLocks xmlns:a="http://schemas.openxmlformats.org/drawingml/2006/main" noGrp="1"/>
-          </p:cNvSpPr>
-          <p:nvPr/>
-        </p:nvSpPr>
-        <p:spPr>
-          <a:xfrm xmlns:a="http://schemas.openxmlformats.org/drawingml/2006/main" rot="0">
+            <a:extLst>
+              <a:ext uri="{FF2B5EF4-FFF2-40B4-BE49-F238E27FC236}">
+                <ns2:creationId id="{E2D97AA9-0F5A-44C5-80E2-1E973617D2B6}"/>
+              </a:ext>
+            </a:extLst>
+          </p:cNvPr>
+          <p:cNvSpPr>
+            <a:spLocks noGrp="1"/>
+          </p:cNvSpPr>
+          <p:nvPr/>
+        </p:nvSpPr>
+        <p:spPr>
+          <a:xfrm rot="0">
             <a:off x="609600" y="1866900"/>
             <a:ext cx="3086100" cy="3829050"/>
           </a:xfrm>
-          <a:prstGeom xmlns:a="http://schemas.openxmlformats.org/drawingml/2006/main" prst="roundRect">
+          <a:prstGeom prst="roundRect">
             <a:avLst>
               <a:gd name="adj" fmla="val 2469"/>
             </a:avLst>
           </a:prstGeom>
-          <a:solidFill xmlns:a="http://schemas.openxmlformats.org/drawingml/2006/main">
+          <a:solidFill>
             <a:srgbClr val="FFFDF8"/>
           </a:solidFill>
-          <a:ln xmlns:a="http://schemas.openxmlformats.org/drawingml/2006/main" w="11430">
+          <a:ln w="11430">
             <a:solidFill>
               <a:srgbClr val="23313B"/>
             </a:solidFill>
@@ -7598,29 +7598,29 @@
       <p:sp>
         <p:nvSpPr>
           <p:cNvPr id="9" name="">
-            <a:extLst xmlns:a="http://schemas.openxmlformats.org/drawingml/2006/main">
-              <a:ext uri="{FF2B5EF4-FFF2-40B4-BE49-F238E27FC236}">
-                <a16:creationId xmlns:a16="http://schemas.microsoft.com/office/drawing/2014/main" id="{63D27DEC-6B05-4C67-A477-7638BE39E9D1}"/>
-              </a:ext>
-            </a:extLst>
-          </p:cNvPr>
-          <p:cNvSpPr>
-            <a:spLocks xmlns:a="http://schemas.openxmlformats.org/drawingml/2006/main" noGrp="1"/>
-          </p:cNvSpPr>
-          <p:nvPr/>
-        </p:nvSpPr>
-        <p:spPr>
-          <a:xfrm xmlns:a="http://schemas.openxmlformats.org/drawingml/2006/main" rot="0">
+            <a:extLst>
+              <a:ext uri="{FF2B5EF4-FFF2-40B4-BE49-F238E27FC236}">
+                <ns2:creationId id="{63D27DEC-6B05-4C67-A477-7638BE39E9D1}"/>
+              </a:ext>
+            </a:extLst>
+          </p:cNvPr>
+          <p:cNvSpPr>
+            <a:spLocks noGrp="1"/>
+          </p:cNvSpPr>
+          <p:nvPr/>
+        </p:nvSpPr>
+        <p:spPr>
+          <a:xfrm rot="0">
             <a:off x="609600" y="1866900"/>
             <a:ext cx="3086100" cy="76200"/>
           </a:xfrm>
-          <a:prstGeom xmlns:a="http://schemas.openxmlformats.org/drawingml/2006/main" prst="rect">
-            <a:avLst/>
-          </a:prstGeom>
-          <a:solidFill xmlns:a="http://schemas.openxmlformats.org/drawingml/2006/main">
+          <a:prstGeom prst="rect">
+            <a:avLst/>
+          </a:prstGeom>
+          <a:solidFill>
             <a:srgbClr val="38B58A"/>
           </a:solidFill>
-          <a:ln xmlns:a="http://schemas.openxmlformats.org/drawingml/2006/main" w="0">
+          <a:ln w="0">
             <a:solidFill>
               <a:srgbClr val="000000">
                 <a:alpha val="0"/>
@@ -7633,31 +7633,31 @@
       <p:sp>
         <p:nvSpPr>
           <p:cNvPr id="10" name="">
-            <a:extLst xmlns:a="http://schemas.openxmlformats.org/drawingml/2006/main">
-              <a:ext uri="{FF2B5EF4-FFF2-40B4-BE49-F238E27FC236}">
-                <a16:creationId xmlns:a16="http://schemas.microsoft.com/office/drawing/2014/main" id="{8BE1C61C-D2ED-4994-BE1B-1F8BE8008F58}"/>
-              </a:ext>
-            </a:extLst>
-          </p:cNvPr>
-          <p:cNvSpPr>
-            <a:spLocks xmlns:a="http://schemas.openxmlformats.org/drawingml/2006/main" noGrp="1"/>
-          </p:cNvSpPr>
-          <p:nvPr/>
-        </p:nvSpPr>
-        <p:spPr>
-          <a:xfrm xmlns:a="http://schemas.openxmlformats.org/drawingml/2006/main" rot="0">
+            <a:extLst>
+              <a:ext uri="{FF2B5EF4-FFF2-40B4-BE49-F238E27FC236}">
+                <ns2:creationId id="{8BE1C61C-D2ED-4994-BE1B-1F8BE8008F58}"/>
+              </a:ext>
+            </a:extLst>
+          </p:cNvPr>
+          <p:cNvSpPr>
+            <a:spLocks noGrp="1"/>
+          </p:cNvSpPr>
+          <p:nvPr/>
+        </p:nvSpPr>
+        <p:spPr>
+          <a:xfrm rot="0">
             <a:off x="800100" y="2038350"/>
             <a:ext cx="2705100" cy="266700"/>
           </a:xfrm>
-          <a:prstGeom xmlns:a="http://schemas.openxmlformats.org/drawingml/2006/main" prst="rect">
-            <a:avLst/>
-          </a:prstGeom>
-          <a:solidFill xmlns:a="http://schemas.openxmlformats.org/drawingml/2006/main">
+          <a:prstGeom prst="rect">
+            <a:avLst/>
+          </a:prstGeom>
+          <a:solidFill>
             <a:srgbClr val="000000">
               <a:alpha val="0"/>
             </a:srgbClr>
           </a:solidFill>
-          <a:ln xmlns:a="http://schemas.openxmlformats.org/drawingml/2006/main" w="0">
+          <a:ln w="0">
             <a:solidFill>
               <a:srgbClr val="000000">
                 <a:alpha val="0"/>
@@ -7667,9 +7667,9 @@
           </a:ln>
         </p:spPr>
         <p:txBody>
-          <a:bodyPr xmlns:a="http://schemas.openxmlformats.org/drawingml/2006/main" lIns="0" tIns="0" rIns="0" bIns="0" anchor="t"/>
-          <a:lstStyle xmlns:a="http://schemas.openxmlformats.org/drawingml/2006/main"/>
-          <a:p xmlns:a="http://schemas.openxmlformats.org/drawingml/2006/main">
+          <a:bodyPr lIns="0" tIns="0" rIns="0" bIns="0" anchor="t"/>
+          <a:lstStyle/>
+          <a:p>
             <a:pPr algn="l">
               <a:defRPr sz="1350" b="1">
                 <a:solidFill>
@@ -7691,31 +7691,31 @@
       <p:sp>
         <p:nvSpPr>
           <p:cNvPr id="11" name="">
-            <a:extLst xmlns:a="http://schemas.openxmlformats.org/drawingml/2006/main">
-              <a:ext uri="{FF2B5EF4-FFF2-40B4-BE49-F238E27FC236}">
-                <a16:creationId xmlns:a16="http://schemas.microsoft.com/office/drawing/2014/main" id="{F12AF1F4-7B0C-47E2-9F27-193F8F78D47C}"/>
-              </a:ext>
-            </a:extLst>
-          </p:cNvPr>
-          <p:cNvSpPr>
-            <a:spLocks xmlns:a="http://schemas.openxmlformats.org/drawingml/2006/main" noGrp="1"/>
-          </p:cNvSpPr>
-          <p:nvPr/>
-        </p:nvSpPr>
-        <p:spPr>
-          <a:xfrm xmlns:a="http://schemas.openxmlformats.org/drawingml/2006/main" rot="0">
+            <a:extLst>
+              <a:ext uri="{FF2B5EF4-FFF2-40B4-BE49-F238E27FC236}">
+                <ns2:creationId id="{F12AF1F4-7B0C-47E2-9F27-193F8F78D47C}"/>
+              </a:ext>
+            </a:extLst>
+          </p:cNvPr>
+          <p:cNvSpPr>
+            <a:spLocks noGrp="1"/>
+          </p:cNvSpPr>
+          <p:nvPr/>
+        </p:nvSpPr>
+        <p:spPr>
+          <a:xfrm rot="0">
             <a:off x="857250" y="2400300"/>
             <a:ext cx="2590800" cy="1943100"/>
           </a:xfrm>
-          <a:prstGeom xmlns:a="http://schemas.openxmlformats.org/drawingml/2006/main" prst="rect">
-            <a:avLst/>
-          </a:prstGeom>
-          <a:solidFill xmlns:a="http://schemas.openxmlformats.org/drawingml/2006/main">
+          <a:prstGeom prst="rect">
+            <a:avLst/>
+          </a:prstGeom>
+          <a:solidFill>
             <a:srgbClr val="000000">
               <a:alpha val="0"/>
             </a:srgbClr>
           </a:solidFill>
-          <a:ln xmlns:a="http://schemas.openxmlformats.org/drawingml/2006/main" w="0">
+          <a:ln w="0">
             <a:solidFill>
               <a:srgbClr val="000000">
                 <a:alpha val="0"/>
@@ -7725,9 +7725,9 @@
           </a:ln>
         </p:spPr>
         <p:txBody>
-          <a:bodyPr xmlns:a="http://schemas.openxmlformats.org/drawingml/2006/main" lIns="0" tIns="0" rIns="0" bIns="0" anchor="t"/>
-          <a:lstStyle xmlns:a="http://schemas.openxmlformats.org/drawingml/2006/main"/>
-          <a:p xmlns:a="http://schemas.openxmlformats.org/drawingml/2006/main">
+          <a:bodyPr lIns="0" tIns="0" rIns="0" bIns="0" anchor="t"/>
+          <a:lstStyle/>
+          <a:p>
             <a:pPr algn="l">
               <a:defRPr sz="1275" b="0">
                 <a:solidFill>
@@ -7741,15 +7741,27 @@
                   <a:srgbClr val="172026"/>
                 </a:solidFill>
               </a:rPr>
-              <a:t>把可替換的演算法封裝在共同介面後面，讓主要執行流程不依賴特定實作。</a:t>
-            </a:r>
-          </a:p>
-          <a:p xmlns:a="http://schemas.openxmlformats.org/drawingml/2006/main">
-            <a:r>
+              <a:t>把不同交易訊號演算法封裝在 TradingStrategy 介面後面。</a:t>
+            </a:r>
+          </a:p>
+          <a:p>
+            <a:pPr algn="l">
+              <a:defRPr sz="1275" b="0">
+                <a:solidFill>
+                  <a:srgbClr val="172026"/>
+                </a:solidFill>
+              </a:defRPr>
+            </a:pPr>
+            <a:r>
+              <a:rPr sz="1275" b="0">
+                <a:solidFill>
+                  <a:srgbClr val="172026"/>
+                </a:solidFill>
+              </a:rPr>
               <a:t/>
             </a:r>
           </a:p>
-          <a:p xmlns:a="http://schemas.openxmlformats.org/drawingml/2006/main">
+          <a:p>
             <a:pPr algn="l">
               <a:defRPr sz="1275" b="0">
                 <a:solidFill>
@@ -7763,7 +7775,7 @@
                   <a:srgbClr val="172026"/>
                 </a:solidFill>
               </a:rPr>
-              <a:t>因此系統可以切換行為，而不必修改 controller 或 service 的主流程。</a:t>
+              <a:t>BacktestEngine 只負責回測流程，不需要知道每種策略如何產生 BUY / SELL 訊號。</a:t>
             </a:r>
           </a:p>
         </p:txBody>
@@ -7771,31 +7783,31 @@
       <p:sp>
         <p:nvSpPr>
           <p:cNvPr id="12" name="">
-            <a:extLst xmlns:a="http://schemas.openxmlformats.org/drawingml/2006/main">
-              <a:ext uri="{FF2B5EF4-FFF2-40B4-BE49-F238E27FC236}">
-                <a16:creationId xmlns:a16="http://schemas.microsoft.com/office/drawing/2014/main" id="{8A236BB3-73B9-4D90-8215-529E74321807}"/>
-              </a:ext>
-            </a:extLst>
-          </p:cNvPr>
-          <p:cNvSpPr>
-            <a:spLocks xmlns:a="http://schemas.openxmlformats.org/drawingml/2006/main" noGrp="1"/>
-          </p:cNvSpPr>
-          <p:nvPr/>
-        </p:nvSpPr>
-        <p:spPr>
-          <a:xfrm xmlns:a="http://schemas.openxmlformats.org/drawingml/2006/main" rot="0">
+            <a:extLst>
+              <a:ext uri="{FF2B5EF4-FFF2-40B4-BE49-F238E27FC236}">
+                <ns2:creationId id="{8A236BB3-73B9-4D90-8215-529E74321807}"/>
+              </a:ext>
+            </a:extLst>
+          </p:cNvPr>
+          <p:cNvSpPr>
+            <a:spLocks noGrp="1"/>
+          </p:cNvSpPr>
+          <p:nvPr/>
+        </p:nvSpPr>
+        <p:spPr>
+          <a:xfrm rot="0">
             <a:off x="4533900" y="1866900"/>
             <a:ext cx="3162300" cy="3829050"/>
           </a:xfrm>
-          <a:prstGeom xmlns:a="http://schemas.openxmlformats.org/drawingml/2006/main" prst="roundRect">
+          <a:prstGeom prst="roundRect">
             <a:avLst>
               <a:gd name="adj" fmla="val 2410"/>
             </a:avLst>
           </a:prstGeom>
-          <a:solidFill xmlns:a="http://schemas.openxmlformats.org/drawingml/2006/main">
+          <a:solidFill>
             <a:srgbClr val="FFFDF8"/>
           </a:solidFill>
-          <a:ln xmlns:a="http://schemas.openxmlformats.org/drawingml/2006/main" w="11430">
+          <a:ln w="11430">
             <a:solidFill>
               <a:srgbClr val="23313B"/>
             </a:solidFill>
@@ -7806,29 +7818,29 @@
       <p:sp>
         <p:nvSpPr>
           <p:cNvPr id="13" name="">
-            <a:extLst xmlns:a="http://schemas.openxmlformats.org/drawingml/2006/main">
-              <a:ext uri="{FF2B5EF4-FFF2-40B4-BE49-F238E27FC236}">
-                <a16:creationId xmlns:a16="http://schemas.microsoft.com/office/drawing/2014/main" id="{D2B0858F-0B0A-4AD0-B910-D2AE624A2B99}"/>
-              </a:ext>
-            </a:extLst>
-          </p:cNvPr>
-          <p:cNvSpPr>
-            <a:spLocks xmlns:a="http://schemas.openxmlformats.org/drawingml/2006/main" noGrp="1"/>
-          </p:cNvSpPr>
-          <p:nvPr/>
-        </p:nvSpPr>
-        <p:spPr>
-          <a:xfrm xmlns:a="http://schemas.openxmlformats.org/drawingml/2006/main" rot="0">
+            <a:extLst>
+              <a:ext uri="{FF2B5EF4-FFF2-40B4-BE49-F238E27FC236}">
+                <ns2:creationId id="{D2B0858F-0B0A-4AD0-B910-D2AE624A2B99}"/>
+              </a:ext>
+            </a:extLst>
+          </p:cNvPr>
+          <p:cNvSpPr>
+            <a:spLocks noGrp="1"/>
+          </p:cNvSpPr>
+          <p:nvPr/>
+        </p:nvSpPr>
+        <p:spPr>
+          <a:xfrm rot="0">
             <a:off x="4533900" y="1866900"/>
             <a:ext cx="3162300" cy="76200"/>
           </a:xfrm>
-          <a:prstGeom xmlns:a="http://schemas.openxmlformats.org/drawingml/2006/main" prst="rect">
-            <a:avLst/>
-          </a:prstGeom>
-          <a:solidFill xmlns:a="http://schemas.openxmlformats.org/drawingml/2006/main">
+          <a:prstGeom prst="rect">
+            <a:avLst/>
+          </a:prstGeom>
+          <a:solidFill>
             <a:srgbClr val="5E9BFF"/>
           </a:solidFill>
-          <a:ln xmlns:a="http://schemas.openxmlformats.org/drawingml/2006/main" w="0">
+          <a:ln w="0">
             <a:solidFill>
               <a:srgbClr val="000000">
                 <a:alpha val="0"/>
@@ -7841,31 +7853,31 @@
       <p:sp>
         <p:nvSpPr>
           <p:cNvPr id="14" name="">
-            <a:extLst xmlns:a="http://schemas.openxmlformats.org/drawingml/2006/main">
-              <a:ext uri="{FF2B5EF4-FFF2-40B4-BE49-F238E27FC236}">
-                <a16:creationId xmlns:a16="http://schemas.microsoft.com/office/drawing/2014/main" id="{86101DFA-9852-459B-B75C-97B95749AB73}"/>
-              </a:ext>
-            </a:extLst>
-          </p:cNvPr>
-          <p:cNvSpPr>
-            <a:spLocks xmlns:a="http://schemas.openxmlformats.org/drawingml/2006/main" noGrp="1"/>
-          </p:cNvSpPr>
-          <p:nvPr/>
-        </p:nvSpPr>
-        <p:spPr>
-          <a:xfrm xmlns:a="http://schemas.openxmlformats.org/drawingml/2006/main" rot="0">
+            <a:extLst>
+              <a:ext uri="{FF2B5EF4-FFF2-40B4-BE49-F238E27FC236}">
+                <ns2:creationId id="{86101DFA-9852-459B-B75C-97B95749AB73}"/>
+              </a:ext>
+            </a:extLst>
+          </p:cNvPr>
+          <p:cNvSpPr>
+            <a:spLocks noGrp="1"/>
+          </p:cNvSpPr>
+          <p:nvPr/>
+        </p:nvSpPr>
+        <p:spPr>
+          <a:xfrm rot="0">
             <a:off x="4724400" y="2038350"/>
             <a:ext cx="2781300" cy="266700"/>
           </a:xfrm>
-          <a:prstGeom xmlns:a="http://schemas.openxmlformats.org/drawingml/2006/main" prst="rect">
-            <a:avLst/>
-          </a:prstGeom>
-          <a:solidFill xmlns:a="http://schemas.openxmlformats.org/drawingml/2006/main">
+          <a:prstGeom prst="rect">
+            <a:avLst/>
+          </a:prstGeom>
+          <a:solidFill>
             <a:srgbClr val="000000">
               <a:alpha val="0"/>
             </a:srgbClr>
           </a:solidFill>
-          <a:ln xmlns:a="http://schemas.openxmlformats.org/drawingml/2006/main" w="0">
+          <a:ln w="0">
             <a:solidFill>
               <a:srgbClr val="000000">
                 <a:alpha val="0"/>
@@ -7875,9 +7887,9 @@
           </a:ln>
         </p:spPr>
         <p:txBody>
-          <a:bodyPr xmlns:a="http://schemas.openxmlformats.org/drawingml/2006/main" lIns="0" tIns="0" rIns="0" bIns="0" anchor="t"/>
-          <a:lstStyle xmlns:a="http://schemas.openxmlformats.org/drawingml/2006/main"/>
-          <a:p xmlns:a="http://schemas.openxmlformats.org/drawingml/2006/main">
+          <a:bodyPr lIns="0" tIns="0" rIns="0" bIns="0" anchor="t"/>
+          <a:lstStyle/>
+          <a:p>
             <a:pPr algn="l">
               <a:defRPr sz="1350" b="1">
                 <a:solidFill>
@@ -7899,31 +7911,31 @@
       <p:sp>
         <p:nvSpPr>
           <p:cNvPr id="15" name="">
-            <a:extLst xmlns:a="http://schemas.openxmlformats.org/drawingml/2006/main">
-              <a:ext uri="{FF2B5EF4-FFF2-40B4-BE49-F238E27FC236}">
-                <a16:creationId xmlns:a16="http://schemas.microsoft.com/office/drawing/2014/main" id="{D2FE6769-9707-40EC-8547-44CF714E1AE8}"/>
-              </a:ext>
-            </a:extLst>
-          </p:cNvPr>
-          <p:cNvSpPr>
-            <a:spLocks xmlns:a="http://schemas.openxmlformats.org/drawingml/2006/main" noGrp="1"/>
-          </p:cNvSpPr>
-          <p:nvPr/>
-        </p:nvSpPr>
-        <p:spPr>
-          <a:xfrm xmlns:a="http://schemas.openxmlformats.org/drawingml/2006/main" rot="0">
+            <a:extLst>
+              <a:ext uri="{FF2B5EF4-FFF2-40B4-BE49-F238E27FC236}">
+                <ns2:creationId id="{D2FE6769-9707-40EC-8547-44CF714E1AE8}"/>
+              </a:ext>
+            </a:extLst>
+          </p:cNvPr>
+          <p:cNvSpPr>
+            <a:spLocks noGrp="1"/>
+          </p:cNvSpPr>
+          <p:nvPr/>
+        </p:nvSpPr>
+        <p:spPr>
+          <a:xfrm rot="0">
             <a:off x="4781550" y="2400300"/>
             <a:ext cx="2667000" cy="2038350"/>
           </a:xfrm>
-          <a:prstGeom xmlns:a="http://schemas.openxmlformats.org/drawingml/2006/main" prst="rect">
-            <a:avLst/>
-          </a:prstGeom>
-          <a:solidFill xmlns:a="http://schemas.openxmlformats.org/drawingml/2006/main">
+          <a:prstGeom prst="rect">
+            <a:avLst/>
+          </a:prstGeom>
+          <a:solidFill>
             <a:srgbClr val="000000">
               <a:alpha val="0"/>
             </a:srgbClr>
           </a:solidFill>
-          <a:ln xmlns:a="http://schemas.openxmlformats.org/drawingml/2006/main" w="0">
+          <a:ln w="0">
             <a:solidFill>
               <a:srgbClr val="000000">
                 <a:alpha val="0"/>
@@ -7933,9 +7945,9 @@
           </a:ln>
         </p:spPr>
         <p:txBody>
-          <a:bodyPr xmlns:a="http://schemas.openxmlformats.org/drawingml/2006/main" lIns="0" tIns="0" rIns="0" bIns="0" anchor="t"/>
-          <a:lstStyle xmlns:a="http://schemas.openxmlformats.org/drawingml/2006/main"/>
-          <a:p xmlns:a="http://schemas.openxmlformats.org/drawingml/2006/main">
+          <a:bodyPr lIns="0" tIns="0" rIns="0" bIns="0" anchor="t"/>
+          <a:lstStyle/>
+          <a:p>
             <a:pPr algn="l">
               <a:defRPr sz="1275" b="0">
                 <a:solidFill>
@@ -7949,10 +7961,10 @@
                   <a:srgbClr val="172026"/>
                 </a:solidFill>
               </a:rPr>
-              <a:t>1. 警示規則</a:t>
-            </a:r>
-          </a:p>
-          <a:p xmlns:a="http://schemas.openxmlformats.org/drawingml/2006/main">
+              <a:t>主要 class 對應</a:t>
+            </a:r>
+          </a:p>
+          <a:p>
             <a:pPr algn="l">
               <a:defRPr sz="1275" b="0">
                 <a:solidFill>
@@ -7966,15 +7978,27 @@
                   <a:srgbClr val="172026"/>
                 </a:solidFill>
               </a:rPr>
-              <a:t>AlertRule -&gt; PriceAboveAlertRule / PriceBelowAlertRule / PercentChange rules</a:t>
-            </a:r>
-          </a:p>
-          <a:p xmlns:a="http://schemas.openxmlformats.org/drawingml/2006/main">
-            <a:r>
+              <a:t>TradingStrategy：定義 getWarmupPeriod() 與 generateSignals()</a:t>
+            </a:r>
+          </a:p>
+          <a:p>
+            <a:pPr algn="l">
+              <a:defRPr sz="1275" b="0">
+                <a:solidFill>
+                  <a:srgbClr val="172026"/>
+                </a:solidFill>
+              </a:defRPr>
+            </a:pPr>
+            <a:r>
+              <a:rPr sz="1275" b="0">
+                <a:solidFill>
+                  <a:srgbClr val="172026"/>
+                </a:solidFill>
+              </a:rPr>
               <a:t/>
             </a:r>
           </a:p>
-          <a:p xmlns:a="http://schemas.openxmlformats.org/drawingml/2006/main">
+          <a:p>
             <a:pPr algn="l">
               <a:defRPr sz="1275" b="0">
                 <a:solidFill>
@@ -7988,10 +8012,10 @@
                   <a:srgbClr val="172026"/>
                 </a:solidFill>
               </a:rPr>
-              <a:t>2. 回測策略</a:t>
-            </a:r>
-          </a:p>
-          <a:p xmlns:a="http://schemas.openxmlformats.org/drawingml/2006/main">
+              <a:t>BacktestEngine：只呼叫 strategy.getWarmupPeriod() 和 strategy.generateSignals()</a:t>
+            </a:r>
+          </a:p>
+          <a:p>
             <a:pPr algn="l">
               <a:defRPr sz="1275" b="0">
                 <a:solidFill>
@@ -8005,7 +8029,24 @@
                   <a:srgbClr val="172026"/>
                 </a:solidFill>
               </a:rPr>
-              <a:t>MovingAverageCrossStrategy 由 BacktestEngine 執行，未來可擴充 RSI 或突破策略。</a:t>
+              <a:t/>
+            </a:r>
+          </a:p>
+          <a:p>
+            <a:pPr algn="l">
+              <a:defRPr sz="1275" b="0">
+                <a:solidFill>
+                  <a:srgbClr val="172026"/>
+                </a:solidFill>
+              </a:defRPr>
+            </a:pPr>
+            <a:r>
+              <a:rPr sz="1275" b="0">
+                <a:solidFill>
+                  <a:srgbClr val="172026"/>
+                </a:solidFill>
+              </a:rPr>
+              <a:t>具體策略：MovingAverageCrossStrategy、RsiReversionStrategy、BreakoutStrategy 等</a:t>
             </a:r>
           </a:p>
         </p:txBody>
@@ -8013,31 +8054,31 @@
       <p:sp>
         <p:nvSpPr>
           <p:cNvPr id="16" name="">
-            <a:extLst xmlns:a="http://schemas.openxmlformats.org/drawingml/2006/main">
-              <a:ext uri="{FF2B5EF4-FFF2-40B4-BE49-F238E27FC236}">
-                <a16:creationId xmlns:a16="http://schemas.microsoft.com/office/drawing/2014/main" id="{318DDFFF-A235-431C-AAEA-490D8D7E6CAC}"/>
-              </a:ext>
-            </a:extLst>
-          </p:cNvPr>
-          <p:cNvSpPr>
-            <a:spLocks xmlns:a="http://schemas.openxmlformats.org/drawingml/2006/main" noGrp="1"/>
-          </p:cNvSpPr>
-          <p:nvPr/>
-        </p:nvSpPr>
-        <p:spPr>
-          <a:xfrm xmlns:a="http://schemas.openxmlformats.org/drawingml/2006/main" rot="0">
+            <a:extLst>
+              <a:ext uri="{FF2B5EF4-FFF2-40B4-BE49-F238E27FC236}">
+                <ns2:creationId id="{318DDFFF-A235-431C-AAEA-490D8D7E6CAC}"/>
+              </a:ext>
+            </a:extLst>
+          </p:cNvPr>
+          <p:cNvSpPr>
+            <a:spLocks noGrp="1"/>
+          </p:cNvSpPr>
+          <p:nvPr/>
+        </p:nvSpPr>
+        <p:spPr>
+          <a:xfrm rot="0">
             <a:off x="8534400" y="1866900"/>
             <a:ext cx="3048000" cy="3829050"/>
           </a:xfrm>
-          <a:prstGeom xmlns:a="http://schemas.openxmlformats.org/drawingml/2006/main" prst="roundRect">
+          <a:prstGeom prst="roundRect">
             <a:avLst>
               <a:gd name="adj" fmla="val 2500"/>
             </a:avLst>
           </a:prstGeom>
-          <a:solidFill xmlns:a="http://schemas.openxmlformats.org/drawingml/2006/main">
+          <a:solidFill>
             <a:srgbClr val="FFFDF8"/>
           </a:solidFill>
-          <a:ln xmlns:a="http://schemas.openxmlformats.org/drawingml/2006/main" w="11430">
+          <a:ln w="11430">
             <a:solidFill>
               <a:srgbClr val="23313B"/>
             </a:solidFill>
@@ -8048,29 +8089,29 @@
       <p:sp>
         <p:nvSpPr>
           <p:cNvPr id="17" name="">
-            <a:extLst xmlns:a="http://schemas.openxmlformats.org/drawingml/2006/main">
-              <a:ext uri="{FF2B5EF4-FFF2-40B4-BE49-F238E27FC236}">
-                <a16:creationId xmlns:a16="http://schemas.microsoft.com/office/drawing/2014/main" id="{ED7973C1-39BF-428C-A40F-7FE2EA56A892}"/>
-              </a:ext>
-            </a:extLst>
-          </p:cNvPr>
-          <p:cNvSpPr>
-            <a:spLocks xmlns:a="http://schemas.openxmlformats.org/drawingml/2006/main" noGrp="1"/>
-          </p:cNvSpPr>
-          <p:nvPr/>
-        </p:nvSpPr>
-        <p:spPr>
-          <a:xfrm xmlns:a="http://schemas.openxmlformats.org/drawingml/2006/main" rot="0">
+            <a:extLst>
+              <a:ext uri="{FF2B5EF4-FFF2-40B4-BE49-F238E27FC236}">
+                <ns2:creationId id="{ED7973C1-39BF-428C-A40F-7FE2EA56A892}"/>
+              </a:ext>
+            </a:extLst>
+          </p:cNvPr>
+          <p:cNvSpPr>
+            <a:spLocks noGrp="1"/>
+          </p:cNvSpPr>
+          <p:nvPr/>
+        </p:nvSpPr>
+        <p:spPr>
+          <a:xfrm rot="0">
             <a:off x="8534400" y="1866900"/>
             <a:ext cx="3048000" cy="76200"/>
           </a:xfrm>
-          <a:prstGeom xmlns:a="http://schemas.openxmlformats.org/drawingml/2006/main" prst="rect">
-            <a:avLst/>
-          </a:prstGeom>
-          <a:solidFill xmlns:a="http://schemas.openxmlformats.org/drawingml/2006/main">
+          <a:prstGeom prst="rect">
+            <a:avLst/>
+          </a:prstGeom>
+          <a:solidFill>
             <a:srgbClr val="D6A04B"/>
           </a:solidFill>
-          <a:ln xmlns:a="http://schemas.openxmlformats.org/drawingml/2006/main" w="0">
+          <a:ln w="0">
             <a:solidFill>
               <a:srgbClr val="000000">
                 <a:alpha val="0"/>
@@ -8083,31 +8124,31 @@
       <p:sp>
         <p:nvSpPr>
           <p:cNvPr id="18" name="">
-            <a:extLst xmlns:a="http://schemas.openxmlformats.org/drawingml/2006/main">
-              <a:ext uri="{FF2B5EF4-FFF2-40B4-BE49-F238E27FC236}">
-                <a16:creationId xmlns:a16="http://schemas.microsoft.com/office/drawing/2014/main" id="{82DA91FA-5E23-46FF-A6A2-1D0E7A894599}"/>
-              </a:ext>
-            </a:extLst>
-          </p:cNvPr>
-          <p:cNvSpPr>
-            <a:spLocks xmlns:a="http://schemas.openxmlformats.org/drawingml/2006/main" noGrp="1"/>
-          </p:cNvSpPr>
-          <p:nvPr/>
-        </p:nvSpPr>
-        <p:spPr>
-          <a:xfrm xmlns:a="http://schemas.openxmlformats.org/drawingml/2006/main" rot="0">
+            <a:extLst>
+              <a:ext uri="{FF2B5EF4-FFF2-40B4-BE49-F238E27FC236}">
+                <ns2:creationId id="{82DA91FA-5E23-46FF-A6A2-1D0E7A894599}"/>
+              </a:ext>
+            </a:extLst>
+          </p:cNvPr>
+          <p:cNvSpPr>
+            <a:spLocks noGrp="1"/>
+          </p:cNvSpPr>
+          <p:nvPr/>
+        </p:nvSpPr>
+        <p:spPr>
+          <a:xfrm rot="0">
             <a:off x="8724900" y="2038350"/>
             <a:ext cx="2667000" cy="266700"/>
           </a:xfrm>
-          <a:prstGeom xmlns:a="http://schemas.openxmlformats.org/drawingml/2006/main" prst="rect">
-            <a:avLst/>
-          </a:prstGeom>
-          <a:solidFill xmlns:a="http://schemas.openxmlformats.org/drawingml/2006/main">
+          <a:prstGeom prst="rect">
+            <a:avLst/>
+          </a:prstGeom>
+          <a:solidFill>
             <a:srgbClr val="000000">
               <a:alpha val="0"/>
             </a:srgbClr>
           </a:solidFill>
-          <a:ln xmlns:a="http://schemas.openxmlformats.org/drawingml/2006/main" w="0">
+          <a:ln w="0">
             <a:solidFill>
               <a:srgbClr val="000000">
                 <a:alpha val="0"/>
@@ -8117,9 +8158,9 @@
           </a:ln>
         </p:spPr>
         <p:txBody>
-          <a:bodyPr xmlns:a="http://schemas.openxmlformats.org/drawingml/2006/main" lIns="0" tIns="0" rIns="0" bIns="0" anchor="t"/>
-          <a:lstStyle xmlns:a="http://schemas.openxmlformats.org/drawingml/2006/main"/>
-          <a:p xmlns:a="http://schemas.openxmlformats.org/drawingml/2006/main">
+          <a:bodyPr lIns="0" tIns="0" rIns="0" bIns="0" anchor="t"/>
+          <a:lstStyle/>
+          <a:p>
             <a:pPr algn="l">
               <a:defRPr sz="1350" b="1">
                 <a:solidFill>
@@ -8141,31 +8182,31 @@
       <p:sp>
         <p:nvSpPr>
           <p:cNvPr id="19" name="">
-            <a:extLst xmlns:a="http://schemas.openxmlformats.org/drawingml/2006/main">
-              <a:ext uri="{FF2B5EF4-FFF2-40B4-BE49-F238E27FC236}">
-                <a16:creationId xmlns:a16="http://schemas.microsoft.com/office/drawing/2014/main" id="{20B49210-D243-454E-A736-E9ABBAEF14EA}"/>
-              </a:ext>
-            </a:extLst>
-          </p:cNvPr>
-          <p:cNvSpPr>
-            <a:spLocks xmlns:a="http://schemas.openxmlformats.org/drawingml/2006/main" noGrp="1"/>
-          </p:cNvSpPr>
-          <p:nvPr/>
-        </p:nvSpPr>
-        <p:spPr>
-          <a:xfrm xmlns:a="http://schemas.openxmlformats.org/drawingml/2006/main" rot="0">
+            <a:extLst>
+              <a:ext uri="{FF2B5EF4-FFF2-40B4-BE49-F238E27FC236}">
+                <ns2:creationId id="{20B49210-D243-454E-A736-E9ABBAEF14EA}"/>
+              </a:ext>
+            </a:extLst>
+          </p:cNvPr>
+          <p:cNvSpPr>
+            <a:spLocks noGrp="1"/>
+          </p:cNvSpPr>
+          <p:nvPr/>
+        </p:nvSpPr>
+        <p:spPr>
+          <a:xfrm rot="0">
             <a:off x="8782050" y="2400300"/>
             <a:ext cx="2552700" cy="1790700"/>
           </a:xfrm>
-          <a:prstGeom xmlns:a="http://schemas.openxmlformats.org/drawingml/2006/main" prst="rect">
-            <a:avLst/>
-          </a:prstGeom>
-          <a:solidFill xmlns:a="http://schemas.openxmlformats.org/drawingml/2006/main">
+          <a:prstGeom prst="rect">
+            <a:avLst/>
+          </a:prstGeom>
+          <a:solidFill>
             <a:srgbClr val="000000">
               <a:alpha val="0"/>
             </a:srgbClr>
           </a:solidFill>
-          <a:ln xmlns:a="http://schemas.openxmlformats.org/drawingml/2006/main" w="0">
+          <a:ln w="0">
             <a:solidFill>
               <a:srgbClr val="000000">
                 <a:alpha val="0"/>
@@ -8175,9 +8216,9 @@
           </a:ln>
         </p:spPr>
         <p:txBody>
-          <a:bodyPr xmlns:a="http://schemas.openxmlformats.org/drawingml/2006/main" lIns="0" tIns="0" rIns="0" bIns="0" anchor="t"/>
-          <a:lstStyle xmlns:a="http://schemas.openxmlformats.org/drawingml/2006/main"/>
-          <a:p xmlns:a="http://schemas.openxmlformats.org/drawingml/2006/main">
+          <a:bodyPr lIns="0" tIns="0" rIns="0" bIns="0" anchor="t"/>
+          <a:lstStyle/>
+          <a:p>
             <a:pPr algn="l">
               <a:defRPr sz="1275" b="0">
                 <a:solidFill>
@@ -8191,10 +8232,10 @@
                   <a:srgbClr val="172026"/>
                 </a:solidFill>
               </a:rPr>
-              <a:t>1. 減少大型 if-else 判斷</a:t>
-            </a:r>
-          </a:p>
-          <a:p xmlns:a="http://schemas.openxmlformats.org/drawingml/2006/main">
+              <a:t>1. 回測流程與策略邏輯分離</a:t>
+            </a:r>
+          </a:p>
+          <a:p>
             <a:pPr algn="l">
               <a:defRPr sz="1275" b="0">
                 <a:solidFill>
@@ -8208,10 +8249,10 @@
                   <a:srgbClr val="172026"/>
                 </a:solidFill>
               </a:rPr>
-              <a:t>2. 提升擴充性</a:t>
-            </a:r>
-          </a:p>
-          <a:p xmlns:a="http://schemas.openxmlformats.org/drawingml/2006/main">
+              <a:t>2. 新增策略時不改 BacktestEngine</a:t>
+            </a:r>
+          </a:p>
+          <a:p>
             <a:pPr algn="l">
               <a:defRPr sz="1275" b="0">
                 <a:solidFill>
@@ -8225,10 +8266,10 @@
                   <a:srgbClr val="172026"/>
                 </a:solidFill>
               </a:rPr>
-              <a:t>3. 讓物件設計更明確</a:t>
-            </a:r>
-          </a:p>
-          <a:p xmlns:a="http://schemas.openxmlformats.org/drawingml/2006/main">
+              <a:t>3. 不同策略可用同一套交易模擬流程</a:t>
+            </a:r>
+          </a:p>
+          <a:p>
             <a:pPr algn="l">
               <a:defRPr sz="1275" b="0">
                 <a:solidFill>
@@ -8242,7 +8283,7 @@
                   <a:srgbClr val="172026"/>
                 </a:solidFill>
               </a:rPr>
-              <a:t>4. 評估器與引擎可保持穩定，只替換演算法</a:t>
+              <a:t>4. 比 Factory 更強調「演算法替換」</a:t>
             </a:r>
           </a:p>
         </p:txBody>
@@ -8250,31 +8291,31 @@
       <p:sp>
         <p:nvSpPr>
           <p:cNvPr id="20" name="">
-            <a:extLst xmlns:a="http://schemas.openxmlformats.org/drawingml/2006/main">
-              <a:ext uri="{FF2B5EF4-FFF2-40B4-BE49-F238E27FC236}">
-                <a16:creationId xmlns:a16="http://schemas.microsoft.com/office/drawing/2014/main" id="{C0A7B2B6-DD8E-4B3F-B93B-A99B9F4C4C2D}"/>
-              </a:ext>
-            </a:extLst>
-          </p:cNvPr>
-          <p:cNvSpPr>
-            <a:spLocks xmlns:a="http://schemas.openxmlformats.org/drawingml/2006/main" noGrp="1"/>
-          </p:cNvSpPr>
-          <p:nvPr/>
-        </p:nvSpPr>
-        <p:spPr>
-          <a:xfrm xmlns:a="http://schemas.openxmlformats.org/drawingml/2006/main" rot="0">
+            <a:extLst>
+              <a:ext uri="{FF2B5EF4-FFF2-40B4-BE49-F238E27FC236}">
+                <ns2:creationId id="{C0A7B2B6-DD8E-4B3F-B93B-A99B9F4C4C2D}"/>
+              </a:ext>
+            </a:extLst>
+          </p:cNvPr>
+          <p:cNvSpPr>
+            <a:spLocks noGrp="1"/>
+          </p:cNvSpPr>
+          <p:nvPr/>
+        </p:nvSpPr>
+        <p:spPr>
+          <a:xfrm rot="0">
             <a:off x="4743450" y="4838700"/>
             <a:ext cx="1085850" cy="457200"/>
           </a:xfrm>
-          <a:prstGeom xmlns:a="http://schemas.openxmlformats.org/drawingml/2006/main" prst="roundRect">
+          <a:prstGeom prst="roundRect">
             <a:avLst>
               <a:gd name="adj" fmla="val 16667"/>
             </a:avLst>
           </a:prstGeom>
-          <a:solidFill xmlns:a="http://schemas.openxmlformats.org/drawingml/2006/main">
+          <a:solidFill>
             <a:srgbClr val="FAEFD9"/>
           </a:solidFill>
-          <a:ln xmlns:a="http://schemas.openxmlformats.org/drawingml/2006/main" w="10478">
+          <a:ln w="10478">
             <a:solidFill>
               <a:srgbClr val="23313B"/>
             </a:solidFill>
@@ -8285,31 +8326,31 @@
       <p:sp>
         <p:nvSpPr>
           <p:cNvPr id="21" name="">
-            <a:extLst xmlns:a="http://schemas.openxmlformats.org/drawingml/2006/main">
-              <a:ext uri="{FF2B5EF4-FFF2-40B4-BE49-F238E27FC236}">
-                <a16:creationId xmlns:a16="http://schemas.microsoft.com/office/drawing/2014/main" id="{A11DDAA1-A2ED-447A-9138-21A3CD77A80A}"/>
-              </a:ext>
-            </a:extLst>
-          </p:cNvPr>
-          <p:cNvSpPr>
-            <a:spLocks xmlns:a="http://schemas.openxmlformats.org/drawingml/2006/main" noGrp="1"/>
-          </p:cNvSpPr>
-          <p:nvPr/>
-        </p:nvSpPr>
-        <p:spPr>
-          <a:xfrm xmlns:a="http://schemas.openxmlformats.org/drawingml/2006/main" rot="0">
+            <a:extLst>
+              <a:ext uri="{FF2B5EF4-FFF2-40B4-BE49-F238E27FC236}">
+                <ns2:creationId id="{A11DDAA1-A2ED-447A-9138-21A3CD77A80A}"/>
+              </a:ext>
+            </a:extLst>
+          </p:cNvPr>
+          <p:cNvSpPr>
+            <a:spLocks noGrp="1"/>
+          </p:cNvSpPr>
+          <p:nvPr/>
+        </p:nvSpPr>
+        <p:spPr>
+          <a:xfrm rot="0">
             <a:off x="4743450" y="4953000"/>
             <a:ext cx="1085850" cy="190500"/>
           </a:xfrm>
-          <a:prstGeom xmlns:a="http://schemas.openxmlformats.org/drawingml/2006/main" prst="rect">
-            <a:avLst/>
-          </a:prstGeom>
-          <a:solidFill xmlns:a="http://schemas.openxmlformats.org/drawingml/2006/main">
+          <a:prstGeom prst="rect">
+            <a:avLst/>
+          </a:prstGeom>
+          <a:solidFill>
             <a:srgbClr val="000000">
               <a:alpha val="0"/>
             </a:srgbClr>
           </a:solidFill>
-          <a:ln xmlns:a="http://schemas.openxmlformats.org/drawingml/2006/main" w="0">
+          <a:ln w="0">
             <a:solidFill>
               <a:srgbClr val="000000">
                 <a:alpha val="0"/>
@@ -8319,9 +8360,9 @@
           </a:ln>
         </p:spPr>
         <p:txBody>
-          <a:bodyPr xmlns:a="http://schemas.openxmlformats.org/drawingml/2006/main" lIns="0" tIns="0" rIns="0" bIns="0" anchor="t"/>
-          <a:lstStyle xmlns:a="http://schemas.openxmlformats.org/drawingml/2006/main"/>
-          <a:p xmlns:a="http://schemas.openxmlformats.org/drawingml/2006/main">
+          <a:bodyPr lIns="0" tIns="0" rIns="0" bIns="0" anchor="t"/>
+          <a:lstStyle/>
+          <a:p>
             <a:pPr algn="ctr">
               <a:defRPr sz="1200" b="1">
                 <a:solidFill>
@@ -8335,7 +8376,7 @@
                   <a:srgbClr val="172026"/>
                 </a:solidFill>
               </a:rPr>
-              <a:t>AlertRule</a:t>
+              <a:t>TradingStrategy</a:t>
             </a:r>
           </a:p>
         </p:txBody>
@@ -8343,29 +8384,29 @@
       <p:sp>
         <p:nvSpPr>
           <p:cNvPr id="22" name="">
-            <a:extLst xmlns:a="http://schemas.openxmlformats.org/drawingml/2006/main">
-              <a:ext uri="{FF2B5EF4-FFF2-40B4-BE49-F238E27FC236}">
-                <a16:creationId xmlns:a16="http://schemas.microsoft.com/office/drawing/2014/main" id="{E558AF6C-33C7-4B7A-9B78-5AD033D4A5A5}"/>
-              </a:ext>
-            </a:extLst>
-          </p:cNvPr>
-          <p:cNvSpPr>
-            <a:spLocks xmlns:a="http://schemas.openxmlformats.org/drawingml/2006/main" noGrp="1"/>
-          </p:cNvSpPr>
-          <p:nvPr/>
-        </p:nvSpPr>
-        <p:spPr>
-          <a:xfrm xmlns:a="http://schemas.openxmlformats.org/drawingml/2006/main" rot="0">
+            <a:extLst>
+              <a:ext uri="{FF2B5EF4-FFF2-40B4-BE49-F238E27FC236}">
+                <ns2:creationId id="{E558AF6C-33C7-4B7A-9B78-5AD033D4A5A5}"/>
+              </a:ext>
+            </a:extLst>
+          </p:cNvPr>
+          <p:cNvSpPr>
+            <a:spLocks noGrp="1"/>
+          </p:cNvSpPr>
+          <p:nvPr/>
+        </p:nvSpPr>
+        <p:spPr>
+          <a:xfrm rot="0">
             <a:off x="5867400" y="4972050"/>
             <a:ext cx="552450" cy="133350"/>
           </a:xfrm>
-          <a:prstGeom xmlns:a="http://schemas.openxmlformats.org/drawingml/2006/main" prst="rightArrow">
-            <a:avLst/>
-          </a:prstGeom>
-          <a:solidFill xmlns:a="http://schemas.openxmlformats.org/drawingml/2006/main">
+          <a:prstGeom prst="rightArrow">
+            <a:avLst/>
+          </a:prstGeom>
+          <a:solidFill>
             <a:srgbClr val="172026"/>
           </a:solidFill>
-          <a:ln xmlns:a="http://schemas.openxmlformats.org/drawingml/2006/main" w="0">
+          <a:ln w="0">
             <a:solidFill>
               <a:srgbClr val="172026"/>
             </a:solidFill>
@@ -8376,31 +8417,31 @@
       <p:sp>
         <p:nvSpPr>
           <p:cNvPr id="23" name="">
-            <a:extLst xmlns:a="http://schemas.openxmlformats.org/drawingml/2006/main">
-              <a:ext uri="{FF2B5EF4-FFF2-40B4-BE49-F238E27FC236}">
-                <a16:creationId xmlns:a16="http://schemas.microsoft.com/office/drawing/2014/main" id="{029B7255-BCA3-4868-B805-CFC532228C13}"/>
-              </a:ext>
-            </a:extLst>
-          </p:cNvPr>
-          <p:cNvSpPr>
-            <a:spLocks xmlns:a="http://schemas.openxmlformats.org/drawingml/2006/main" noGrp="1"/>
-          </p:cNvSpPr>
-          <p:nvPr/>
-        </p:nvSpPr>
-        <p:spPr>
-          <a:xfrm xmlns:a="http://schemas.openxmlformats.org/drawingml/2006/main" rot="0">
+            <a:extLst>
+              <a:ext uri="{FF2B5EF4-FFF2-40B4-BE49-F238E27FC236}">
+                <ns2:creationId id="{029B7255-BCA3-4868-B805-CFC532228C13}"/>
+              </a:ext>
+            </a:extLst>
+          </p:cNvPr>
+          <p:cNvSpPr>
+            <a:spLocks noGrp="1"/>
+          </p:cNvSpPr>
+          <p:nvPr/>
+        </p:nvSpPr>
+        <p:spPr>
+          <a:xfrm rot="0">
             <a:off x="6553200" y="4686300"/>
             <a:ext cx="952500" cy="342900"/>
           </a:xfrm>
-          <a:prstGeom xmlns:a="http://schemas.openxmlformats.org/drawingml/2006/main" prst="roundRect">
+          <a:prstGeom prst="roundRect">
             <a:avLst>
               <a:gd name="adj" fmla="val 22222"/>
             </a:avLst>
           </a:prstGeom>
-          <a:solidFill xmlns:a="http://schemas.openxmlformats.org/drawingml/2006/main">
+          <a:solidFill>
             <a:srgbClr val="DFF5EC"/>
           </a:solidFill>
-          <a:ln xmlns:a="http://schemas.openxmlformats.org/drawingml/2006/main" w="10478">
+          <a:ln w="10478">
             <a:solidFill>
               <a:srgbClr val="23313B"/>
             </a:solidFill>
@@ -8411,31 +8452,31 @@
       <p:sp>
         <p:nvSpPr>
           <p:cNvPr id="24" name="">
-            <a:extLst xmlns:a="http://schemas.openxmlformats.org/drawingml/2006/main">
-              <a:ext uri="{FF2B5EF4-FFF2-40B4-BE49-F238E27FC236}">
-                <a16:creationId xmlns:a16="http://schemas.microsoft.com/office/drawing/2014/main" id="{0BD610A4-C657-4105-A5CF-A9E58859D63E}"/>
-              </a:ext>
-            </a:extLst>
-          </p:cNvPr>
-          <p:cNvSpPr>
-            <a:spLocks xmlns:a="http://schemas.openxmlformats.org/drawingml/2006/main" noGrp="1"/>
-          </p:cNvSpPr>
-          <p:nvPr/>
-        </p:nvSpPr>
-        <p:spPr>
-          <a:xfrm xmlns:a="http://schemas.openxmlformats.org/drawingml/2006/main" rot="0">
+            <a:extLst>
+              <a:ext uri="{FF2B5EF4-FFF2-40B4-BE49-F238E27FC236}">
+                <ns2:creationId id="{0BD610A4-C657-4105-A5CF-A9E58859D63E}"/>
+              </a:ext>
+            </a:extLst>
+          </p:cNvPr>
+          <p:cNvSpPr>
+            <a:spLocks noGrp="1"/>
+          </p:cNvSpPr>
+          <p:nvPr/>
+        </p:nvSpPr>
+        <p:spPr>
+          <a:xfrm rot="0">
             <a:off x="6553200" y="4772025"/>
             <a:ext cx="952500" cy="171450"/>
           </a:xfrm>
-          <a:prstGeom xmlns:a="http://schemas.openxmlformats.org/drawingml/2006/main" prst="rect">
-            <a:avLst/>
-          </a:prstGeom>
-          <a:solidFill xmlns:a="http://schemas.openxmlformats.org/drawingml/2006/main">
+          <a:prstGeom prst="rect">
+            <a:avLst/>
+          </a:prstGeom>
+          <a:solidFill>
             <a:srgbClr val="000000">
               <a:alpha val="0"/>
             </a:srgbClr>
           </a:solidFill>
-          <a:ln xmlns:a="http://schemas.openxmlformats.org/drawingml/2006/main" w="0">
+          <a:ln w="0">
             <a:solidFill>
               <a:srgbClr val="000000">
                 <a:alpha val="0"/>
@@ -8445,9 +8486,9 @@
           </a:ln>
         </p:spPr>
         <p:txBody>
-          <a:bodyPr xmlns:a="http://schemas.openxmlformats.org/drawingml/2006/main" lIns="0" tIns="0" rIns="0" bIns="0" anchor="t"/>
-          <a:lstStyle xmlns:a="http://schemas.openxmlformats.org/drawingml/2006/main"/>
-          <a:p xmlns:a="http://schemas.openxmlformats.org/drawingml/2006/main">
+          <a:bodyPr lIns="0" tIns="0" rIns="0" bIns="0" anchor="t"/>
+          <a:lstStyle/>
+          <a:p>
             <a:pPr algn="ctr">
               <a:defRPr sz="975" b="1">
                 <a:solidFill>
@@ -8461,7 +8502,7 @@
                   <a:srgbClr val="172026"/>
                 </a:solidFill>
               </a:rPr>
-              <a:t>PriceAbove</a:t>
+              <a:t>MA Cross</a:t>
             </a:r>
           </a:p>
         </p:txBody>
@@ -8469,31 +8510,31 @@
       <p:sp>
         <p:nvSpPr>
           <p:cNvPr id="25" name="">
-            <a:extLst xmlns:a="http://schemas.openxmlformats.org/drawingml/2006/main">
-              <a:ext uri="{FF2B5EF4-FFF2-40B4-BE49-F238E27FC236}">
-                <a16:creationId xmlns:a16="http://schemas.microsoft.com/office/drawing/2014/main" id="{428D9EA6-AEA6-4AF6-B999-4EBB07F3C40A}"/>
-              </a:ext>
-            </a:extLst>
-          </p:cNvPr>
-          <p:cNvSpPr>
-            <a:spLocks xmlns:a="http://schemas.openxmlformats.org/drawingml/2006/main" noGrp="1"/>
-          </p:cNvSpPr>
-          <p:nvPr/>
-        </p:nvSpPr>
-        <p:spPr>
-          <a:xfrm xmlns:a="http://schemas.openxmlformats.org/drawingml/2006/main" rot="0">
+            <a:extLst>
+              <a:ext uri="{FF2B5EF4-FFF2-40B4-BE49-F238E27FC236}">
+                <ns2:creationId id="{428D9EA6-AEA6-4AF6-B999-4EBB07F3C40A}"/>
+              </a:ext>
+            </a:extLst>
+          </p:cNvPr>
+          <p:cNvSpPr>
+            <a:spLocks noGrp="1"/>
+          </p:cNvSpPr>
+          <p:nvPr/>
+        </p:nvSpPr>
+        <p:spPr>
+          <a:xfrm rot="0">
             <a:off x="6553200" y="5105400"/>
             <a:ext cx="952500" cy="342900"/>
           </a:xfrm>
-          <a:prstGeom xmlns:a="http://schemas.openxmlformats.org/drawingml/2006/main" prst="roundRect">
+          <a:prstGeom prst="roundRect">
             <a:avLst>
               <a:gd name="adj" fmla="val 22222"/>
             </a:avLst>
           </a:prstGeom>
-          <a:solidFill xmlns:a="http://schemas.openxmlformats.org/drawingml/2006/main">
+          <a:solidFill>
             <a:srgbClr val="E5EEFF"/>
           </a:solidFill>
-          <a:ln xmlns:a="http://schemas.openxmlformats.org/drawingml/2006/main" w="10478">
+          <a:ln w="10478">
             <a:solidFill>
               <a:srgbClr val="23313B"/>
             </a:solidFill>
@@ -8504,31 +8545,31 @@
       <p:sp>
         <p:nvSpPr>
           <p:cNvPr id="26" name="">
-            <a:extLst xmlns:a="http://schemas.openxmlformats.org/drawingml/2006/main">
-              <a:ext uri="{FF2B5EF4-FFF2-40B4-BE49-F238E27FC236}">
-                <a16:creationId xmlns:a16="http://schemas.microsoft.com/office/drawing/2014/main" id="{63E9EC2B-A303-4243-BB89-D11D7FA72973}"/>
-              </a:ext>
-            </a:extLst>
-          </p:cNvPr>
-          <p:cNvSpPr>
-            <a:spLocks xmlns:a="http://schemas.openxmlformats.org/drawingml/2006/main" noGrp="1"/>
-          </p:cNvSpPr>
-          <p:nvPr/>
-        </p:nvSpPr>
-        <p:spPr>
-          <a:xfrm xmlns:a="http://schemas.openxmlformats.org/drawingml/2006/main" rot="0">
+            <a:extLst>
+              <a:ext uri="{FF2B5EF4-FFF2-40B4-BE49-F238E27FC236}">
+                <ns2:creationId id="{63E9EC2B-A303-4243-BB89-D11D7FA72973}"/>
+              </a:ext>
+            </a:extLst>
+          </p:cNvPr>
+          <p:cNvSpPr>
+            <a:spLocks noGrp="1"/>
+          </p:cNvSpPr>
+          <p:nvPr/>
+        </p:nvSpPr>
+        <p:spPr>
+          <a:xfrm rot="0">
             <a:off x="6553200" y="5191125"/>
             <a:ext cx="952500" cy="171450"/>
           </a:xfrm>
-          <a:prstGeom xmlns:a="http://schemas.openxmlformats.org/drawingml/2006/main" prst="rect">
-            <a:avLst/>
-          </a:prstGeom>
-          <a:solidFill xmlns:a="http://schemas.openxmlformats.org/drawingml/2006/main">
+          <a:prstGeom prst="rect">
+            <a:avLst/>
+          </a:prstGeom>
+          <a:solidFill>
             <a:srgbClr val="000000">
               <a:alpha val="0"/>
             </a:srgbClr>
           </a:solidFill>
-          <a:ln xmlns:a="http://schemas.openxmlformats.org/drawingml/2006/main" w="0">
+          <a:ln w="0">
             <a:solidFill>
               <a:srgbClr val="000000">
                 <a:alpha val="0"/>
@@ -8538,9 +8579,9 @@
           </a:ln>
         </p:spPr>
         <p:txBody>
-          <a:bodyPr xmlns:a="http://schemas.openxmlformats.org/drawingml/2006/main" lIns="0" tIns="0" rIns="0" bIns="0" anchor="t"/>
-          <a:lstStyle xmlns:a="http://schemas.openxmlformats.org/drawingml/2006/main"/>
-          <a:p xmlns:a="http://schemas.openxmlformats.org/drawingml/2006/main">
+          <a:bodyPr lIns="0" tIns="0" rIns="0" bIns="0" anchor="t"/>
+          <a:lstStyle/>
+          <a:p>
             <a:pPr algn="ctr">
               <a:defRPr sz="975" b="1">
                 <a:solidFill>
@@ -8554,7 +8595,7 @@
                   <a:srgbClr val="172026"/>
                 </a:solidFill>
               </a:rPr>
-              <a:t>PercentChange</a:t>
+              <a:t>RSI / Breakout</a:t>
             </a:r>
           </a:p>
         </p:txBody>
@@ -8562,31 +8603,31 @@
       <p:sp>
         <p:nvSpPr>
           <p:cNvPr id="27" name="">
-            <a:extLst xmlns:a="http://schemas.openxmlformats.org/drawingml/2006/main">
-              <a:ext uri="{FF2B5EF4-FFF2-40B4-BE49-F238E27FC236}">
-                <a16:creationId xmlns:a16="http://schemas.microsoft.com/office/drawing/2014/main" id="{80A9362A-C429-4659-8FD6-5D3ED8A3C8AB}"/>
-              </a:ext>
-            </a:extLst>
-          </p:cNvPr>
-          <p:cNvSpPr>
-            <a:spLocks xmlns:a="http://schemas.openxmlformats.org/drawingml/2006/main" noGrp="1"/>
-          </p:cNvSpPr>
-          <p:nvPr/>
-        </p:nvSpPr>
-        <p:spPr>
-          <a:xfrm xmlns:a="http://schemas.openxmlformats.org/drawingml/2006/main" rot="0">
+            <a:extLst>
+              <a:ext uri="{FF2B5EF4-FFF2-40B4-BE49-F238E27FC236}">
+                <ns2:creationId id="{80A9362A-C429-4659-8FD6-5D3ED8A3C8AB}"/>
+              </a:ext>
+            </a:extLst>
+          </p:cNvPr>
+          <p:cNvSpPr>
+            <a:spLocks noGrp="1"/>
+          </p:cNvSpPr>
+          <p:nvPr/>
+        </p:nvSpPr>
+        <p:spPr>
+          <a:xfrm rot="0">
             <a:off x="609600" y="6534150"/>
             <a:ext cx="9715500" cy="171450"/>
           </a:xfrm>
-          <a:prstGeom xmlns:a="http://schemas.openxmlformats.org/drawingml/2006/main" prst="rect">
-            <a:avLst/>
-          </a:prstGeom>
-          <a:solidFill xmlns:a="http://schemas.openxmlformats.org/drawingml/2006/main">
+          <a:prstGeom prst="rect">
+            <a:avLst/>
+          </a:prstGeom>
+          <a:solidFill>
             <a:srgbClr val="000000">
               <a:alpha val="0"/>
             </a:srgbClr>
           </a:solidFill>
-          <a:ln xmlns:a="http://schemas.openxmlformats.org/drawingml/2006/main" w="0">
+          <a:ln w="0">
             <a:solidFill>
               <a:srgbClr val="000000">
                 <a:alpha val="0"/>
@@ -8596,9 +8637,9 @@
           </a:ln>
         </p:spPr>
         <p:txBody>
-          <a:bodyPr xmlns:a="http://schemas.openxmlformats.org/drawingml/2006/main" lIns="0" tIns="0" rIns="0" bIns="0" anchor="t"/>
-          <a:lstStyle xmlns:a="http://schemas.openxmlformats.org/drawingml/2006/main"/>
-          <a:p xmlns:a="http://schemas.openxmlformats.org/drawingml/2006/main">
+          <a:bodyPr lIns="0" tIns="0" rIns="0" bIns="0" anchor="t"/>
+          <a:lstStyle/>
+          <a:p>
             <a:pPr algn="l">
               <a:defRPr sz="750" b="0">
                 <a:solidFill>
@@ -8620,7 +8661,7 @@
     </p:spTree>
     <p:extLst>
       <p:ext uri="{BB962C8B-B14F-4D97-AF65-F5344CB8AC3E}">
-        <p14:creationId xmlns:p14="http://schemas.microsoft.com/office/powerpoint/2010/main" val="868772418"/>
+        <ns3:creationId val="868772418"/>
       </p:ext>
     </p:extLst>
   </p:cSld>
@@ -8628,11 +8669,11 @@
 </file>
 
 <file path=ppt/slides/slide12.xml><?xml version="1.0" encoding="utf-8"?>
-<p:sld xmlns:p="http://schemas.openxmlformats.org/presentationml/2006/main">
+<p:sld xmlns:a="http://schemas.openxmlformats.org/drawingml/2006/main" xmlns:ns2="http://schemas.microsoft.com/office/drawing/2014/main" xmlns:ns3="http://schemas.microsoft.com/office/powerpoint/2010/main" xmlns:p="http://schemas.openxmlformats.org/presentationml/2006/main">
   <p:cSld>
     <p:bg>
       <p:bgPr>
-        <a:solidFill xmlns:a="http://schemas.openxmlformats.org/drawingml/2006/main">
+        <a:solidFill>
           <a:srgbClr val="F5F1E8"/>
         </a:solidFill>
       </p:bgPr>
@@ -8644,34 +8685,34 @@
         <p:nvPr/>
       </p:nvGrpSpPr>
       <p:grpSpPr>
-        <a:xfrm xmlns:a="http://schemas.openxmlformats.org/drawingml/2006/main"/>
+        <a:xfrm/>
       </p:grpSpPr>
       <p:sp>
         <p:nvSpPr>
           <p:cNvPr id="1" name="">
-            <a:extLst xmlns:a="http://schemas.openxmlformats.org/drawingml/2006/main">
-              <a:ext uri="{FF2B5EF4-FFF2-40B4-BE49-F238E27FC236}">
-                <a16:creationId xmlns:a16="http://schemas.microsoft.com/office/drawing/2014/main" id="{C728322D-3D86-4B09-B39C-917C2B112803}"/>
-              </a:ext>
-            </a:extLst>
-          </p:cNvPr>
-          <p:cNvSpPr>
-            <a:spLocks xmlns:a="http://schemas.openxmlformats.org/drawingml/2006/main" noGrp="1"/>
-          </p:cNvSpPr>
-          <p:nvPr/>
-        </p:nvSpPr>
-        <p:spPr>
-          <a:xfrm xmlns:a="http://schemas.openxmlformats.org/drawingml/2006/main" rot="0">
+            <a:extLst>
+              <a:ext uri="{FF2B5EF4-FFF2-40B4-BE49-F238E27FC236}">
+                <ns2:creationId id="{C728322D-3D86-4B09-B39C-917C2B112803}"/>
+              </a:ext>
+            </a:extLst>
+          </p:cNvPr>
+          <p:cNvSpPr>
+            <a:spLocks noGrp="1"/>
+          </p:cNvSpPr>
+          <p:nvPr/>
+        </p:nvSpPr>
+        <p:spPr>
+          <a:xfrm rot="0">
             <a:off x="9620250" y="-857250"/>
             <a:ext cx="3429000" cy="3429000"/>
           </a:xfrm>
-          <a:prstGeom xmlns:a="http://schemas.openxmlformats.org/drawingml/2006/main" prst="ellipse">
-            <a:avLst/>
-          </a:prstGeom>
-          <a:solidFill xmlns:a="http://schemas.openxmlformats.org/drawingml/2006/main">
+          <a:prstGeom prst="ellipse">
+            <a:avLst/>
+          </a:prstGeom>
+          <a:solidFill>
             <a:srgbClr val="DFF5EC"/>
           </a:solidFill>
-          <a:ln xmlns:a="http://schemas.openxmlformats.org/drawingml/2006/main" w="0">
+          <a:ln w="0">
             <a:solidFill>
               <a:srgbClr val="000000">
                 <a:alpha val="0"/>
@@ -8684,29 +8725,29 @@
       <p:sp>
         <p:nvSpPr>
           <p:cNvPr id="2" name="">
-            <a:extLst xmlns:a="http://schemas.openxmlformats.org/drawingml/2006/main">
-              <a:ext uri="{FF2B5EF4-FFF2-40B4-BE49-F238E27FC236}">
-                <a16:creationId xmlns:a16="http://schemas.microsoft.com/office/drawing/2014/main" id="{AFBB68BD-2E52-4C6C-9C63-304F6D7ACE21}"/>
-              </a:ext>
-            </a:extLst>
-          </p:cNvPr>
-          <p:cNvSpPr>
-            <a:spLocks xmlns:a="http://schemas.openxmlformats.org/drawingml/2006/main" noGrp="1"/>
-          </p:cNvSpPr>
-          <p:nvPr/>
-        </p:nvSpPr>
-        <p:spPr>
-          <a:xfrm xmlns:a="http://schemas.openxmlformats.org/drawingml/2006/main" rot="0">
+            <a:extLst>
+              <a:ext uri="{FF2B5EF4-FFF2-40B4-BE49-F238E27FC236}">
+                <ns2:creationId id="{AFBB68BD-2E52-4C6C-9C63-304F6D7ACE21}"/>
+              </a:ext>
+            </a:extLst>
+          </p:cNvPr>
+          <p:cNvSpPr>
+            <a:spLocks noGrp="1"/>
+          </p:cNvSpPr>
+          <p:nvPr/>
+        </p:nvSpPr>
+        <p:spPr>
+          <a:xfrm rot="0">
             <a:off x="-857250" y="5334000"/>
             <a:ext cx="2286000" cy="2286000"/>
           </a:xfrm>
-          <a:prstGeom xmlns:a="http://schemas.openxmlformats.org/drawingml/2006/main" prst="ellipse">
-            <a:avLst/>
-          </a:prstGeom>
-          <a:solidFill xmlns:a="http://schemas.openxmlformats.org/drawingml/2006/main">
+          <a:prstGeom prst="ellipse">
+            <a:avLst/>
+          </a:prstGeom>
+          <a:solidFill>
             <a:srgbClr val="FAEFD9"/>
           </a:solidFill>
-          <a:ln xmlns:a="http://schemas.openxmlformats.org/drawingml/2006/main" w="0">
+          <a:ln w="0">
             <a:solidFill>
               <a:srgbClr val="000000">
                 <a:alpha val="0"/>
@@ -8719,31 +8760,31 @@
       <p:sp>
         <p:nvSpPr>
           <p:cNvPr id="3" name="">
-            <a:extLst xmlns:a="http://schemas.openxmlformats.org/drawingml/2006/main">
-              <a:ext uri="{FF2B5EF4-FFF2-40B4-BE49-F238E27FC236}">
-                <a16:creationId xmlns:a16="http://schemas.microsoft.com/office/drawing/2014/main" id="{F08D0F6B-CF2D-4D11-9F97-C807ABEB7409}"/>
-              </a:ext>
-            </a:extLst>
-          </p:cNvPr>
-          <p:cNvSpPr>
-            <a:spLocks xmlns:a="http://schemas.openxmlformats.org/drawingml/2006/main" noGrp="1"/>
-          </p:cNvSpPr>
-          <p:nvPr/>
-        </p:nvSpPr>
-        <p:spPr>
-          <a:xfrm xmlns:a="http://schemas.openxmlformats.org/drawingml/2006/main" rot="0">
+            <a:extLst>
+              <a:ext uri="{FF2B5EF4-FFF2-40B4-BE49-F238E27FC236}">
+                <ns2:creationId id="{F08D0F6B-CF2D-4D11-9F97-C807ABEB7409}"/>
+              </a:ext>
+            </a:extLst>
+          </p:cNvPr>
+          <p:cNvSpPr>
+            <a:spLocks noGrp="1"/>
+          </p:cNvSpPr>
+          <p:nvPr/>
+        </p:nvSpPr>
+        <p:spPr>
+          <a:xfrm rot="0">
             <a:off x="609600" y="266700"/>
             <a:ext cx="3429000" cy="171450"/>
           </a:xfrm>
-          <a:prstGeom xmlns:a="http://schemas.openxmlformats.org/drawingml/2006/main" prst="rect">
-            <a:avLst/>
-          </a:prstGeom>
-          <a:solidFill xmlns:a="http://schemas.openxmlformats.org/drawingml/2006/main">
+          <a:prstGeom prst="rect">
+            <a:avLst/>
+          </a:prstGeom>
+          <a:solidFill>
             <a:srgbClr val="000000">
               <a:alpha val="0"/>
             </a:srgbClr>
           </a:solidFill>
-          <a:ln xmlns:a="http://schemas.openxmlformats.org/drawingml/2006/main" w="0">
+          <a:ln w="0">
             <a:solidFill>
               <a:srgbClr val="000000">
                 <a:alpha val="0"/>
@@ -8753,9 +8794,9 @@
           </a:ln>
         </p:spPr>
         <p:txBody>
-          <a:bodyPr xmlns:a="http://schemas.openxmlformats.org/drawingml/2006/main" lIns="0" tIns="0" rIns="0" bIns="0" anchor="t"/>
-          <a:lstStyle xmlns:a="http://schemas.openxmlformats.org/drawingml/2006/main"/>
-          <a:p xmlns:a="http://schemas.openxmlformats.org/drawingml/2006/main">
+          <a:bodyPr lIns="0" tIns="0" rIns="0" bIns="0" anchor="t"/>
+          <a:lstStyle/>
+          <a:p>
             <a:pPr algn="l">
               <a:defRPr sz="825" b="1">
                 <a:solidFill>
@@ -8777,31 +8818,31 @@
       <p:sp>
         <p:nvSpPr>
           <p:cNvPr id="4" name="">
-            <a:extLst xmlns:a="http://schemas.openxmlformats.org/drawingml/2006/main">
-              <a:ext uri="{FF2B5EF4-FFF2-40B4-BE49-F238E27FC236}">
-                <a16:creationId xmlns:a16="http://schemas.microsoft.com/office/drawing/2014/main" id="{458B74BF-30F1-43A1-B73C-16DA7C548F5B}"/>
-              </a:ext>
-            </a:extLst>
-          </p:cNvPr>
-          <p:cNvSpPr>
-            <a:spLocks xmlns:a="http://schemas.openxmlformats.org/drawingml/2006/main" noGrp="1"/>
-          </p:cNvSpPr>
-          <p:nvPr/>
-        </p:nvSpPr>
-        <p:spPr>
-          <a:xfrm xmlns:a="http://schemas.openxmlformats.org/drawingml/2006/main" rot="0">
+            <a:extLst>
+              <a:ext uri="{FF2B5EF4-FFF2-40B4-BE49-F238E27FC236}">
+                <ns2:creationId id="{458B74BF-30F1-43A1-B73C-16DA7C548F5B}"/>
+              </a:ext>
+            </a:extLst>
+          </p:cNvPr>
+          <p:cNvSpPr>
+            <a:spLocks noGrp="1"/>
+          </p:cNvSpPr>
+          <p:nvPr/>
+        </p:nvSpPr>
+        <p:spPr>
+          <a:xfrm rot="0">
             <a:off x="11163300" y="247650"/>
             <a:ext cx="419100" cy="190500"/>
           </a:xfrm>
-          <a:prstGeom xmlns:a="http://schemas.openxmlformats.org/drawingml/2006/main" prst="rect">
-            <a:avLst/>
-          </a:prstGeom>
-          <a:solidFill xmlns:a="http://schemas.openxmlformats.org/drawingml/2006/main">
+          <a:prstGeom prst="rect">
+            <a:avLst/>
+          </a:prstGeom>
+          <a:solidFill>
             <a:srgbClr val="000000">
               <a:alpha val="0"/>
             </a:srgbClr>
           </a:solidFill>
-          <a:ln xmlns:a="http://schemas.openxmlformats.org/drawingml/2006/main" w="0">
+          <a:ln w="0">
             <a:solidFill>
               <a:srgbClr val="000000">
                 <a:alpha val="0"/>
@@ -8811,9 +8852,9 @@
           </a:ln>
         </p:spPr>
         <p:txBody>
-          <a:bodyPr xmlns:a="http://schemas.openxmlformats.org/drawingml/2006/main" lIns="0" tIns="0" rIns="0" bIns="0" anchor="t"/>
-          <a:lstStyle xmlns:a="http://schemas.openxmlformats.org/drawingml/2006/main"/>
-          <a:p xmlns:a="http://schemas.openxmlformats.org/drawingml/2006/main">
+          <a:bodyPr lIns="0" tIns="0" rIns="0" bIns="0" anchor="t"/>
+          <a:lstStyle/>
+          <a:p>
             <a:pPr algn="r">
               <a:defRPr sz="900" b="1">
                 <a:solidFill>
@@ -8835,29 +8876,29 @@
       <p:sp>
         <p:nvSpPr>
           <p:cNvPr id="5" name="">
-            <a:extLst xmlns:a="http://schemas.openxmlformats.org/drawingml/2006/main">
-              <a:ext uri="{FF2B5EF4-FFF2-40B4-BE49-F238E27FC236}">
-                <a16:creationId xmlns:a16="http://schemas.microsoft.com/office/drawing/2014/main" id="{FCF240D4-74A8-466F-AE56-682EAD24CD82}"/>
-              </a:ext>
-            </a:extLst>
-          </p:cNvPr>
-          <p:cNvSpPr>
-            <a:spLocks xmlns:a="http://schemas.openxmlformats.org/drawingml/2006/main" noGrp="1"/>
-          </p:cNvSpPr>
-          <p:nvPr/>
-        </p:nvSpPr>
-        <p:spPr>
-          <a:xfrm xmlns:a="http://schemas.openxmlformats.org/drawingml/2006/main" rot="0">
+            <a:extLst>
+              <a:ext uri="{FF2B5EF4-FFF2-40B4-BE49-F238E27FC236}">
+                <ns2:creationId id="{FCF240D4-74A8-466F-AE56-682EAD24CD82}"/>
+              </a:ext>
+            </a:extLst>
+          </p:cNvPr>
+          <p:cNvSpPr>
+            <a:spLocks noGrp="1"/>
+          </p:cNvSpPr>
+          <p:nvPr/>
+        </p:nvSpPr>
+        <p:spPr>
+          <a:xfrm rot="0">
             <a:off x="609600" y="514350"/>
             <a:ext cx="10972800" cy="19050"/>
           </a:xfrm>
-          <a:prstGeom xmlns:a="http://schemas.openxmlformats.org/drawingml/2006/main" prst="rect">
-            <a:avLst/>
-          </a:prstGeom>
-          <a:solidFill xmlns:a="http://schemas.openxmlformats.org/drawingml/2006/main">
+          <a:prstGeom prst="rect">
+            <a:avLst/>
+          </a:prstGeom>
+          <a:solidFill>
             <a:srgbClr val="23313B"/>
           </a:solidFill>
-          <a:ln xmlns:a="http://schemas.openxmlformats.org/drawingml/2006/main" w="0">
+          <a:ln w="0">
             <a:solidFill>
               <a:srgbClr val="000000">
                 <a:alpha val="0"/>
@@ -8870,31 +8911,31 @@
       <p:sp>
         <p:nvSpPr>
           <p:cNvPr id="6" name="">
-            <a:extLst xmlns:a="http://schemas.openxmlformats.org/drawingml/2006/main">
-              <a:ext uri="{FF2B5EF4-FFF2-40B4-BE49-F238E27FC236}">
-                <a16:creationId xmlns:a16="http://schemas.microsoft.com/office/drawing/2014/main" id="{965B99A4-3384-48EB-B227-11523E5F4252}"/>
-              </a:ext>
-            </a:extLst>
-          </p:cNvPr>
-          <p:cNvSpPr>
-            <a:spLocks xmlns:a="http://schemas.openxmlformats.org/drawingml/2006/main" noGrp="1"/>
-          </p:cNvSpPr>
-          <p:nvPr/>
-        </p:nvSpPr>
-        <p:spPr>
-          <a:xfrm xmlns:a="http://schemas.openxmlformats.org/drawingml/2006/main" rot="0">
+            <a:extLst>
+              <a:ext uri="{FF2B5EF4-FFF2-40B4-BE49-F238E27FC236}">
+                <ns2:creationId id="{965B99A4-3384-48EB-B227-11523E5F4252}"/>
+              </a:ext>
+            </a:extLst>
+          </p:cNvPr>
+          <p:cNvSpPr>
+            <a:spLocks noGrp="1"/>
+          </p:cNvSpPr>
+          <p:nvPr/>
+        </p:nvSpPr>
+        <p:spPr>
+          <a:xfrm rot="0">
             <a:off x="609600" y="781050"/>
             <a:ext cx="8858250" cy="514350"/>
           </a:xfrm>
-          <a:prstGeom xmlns:a="http://schemas.openxmlformats.org/drawingml/2006/main" prst="rect">
-            <a:avLst/>
-          </a:prstGeom>
-          <a:solidFill xmlns:a="http://schemas.openxmlformats.org/drawingml/2006/main">
+          <a:prstGeom prst="rect">
+            <a:avLst/>
+          </a:prstGeom>
+          <a:solidFill>
             <a:srgbClr val="000000">
               <a:alpha val="0"/>
             </a:srgbClr>
           </a:solidFill>
-          <a:ln xmlns:a="http://schemas.openxmlformats.org/drawingml/2006/main" w="0">
+          <a:ln w="0">
             <a:solidFill>
               <a:srgbClr val="000000">
                 <a:alpha val="0"/>
@@ -8904,9 +8945,9 @@
           </a:ln>
         </p:spPr>
         <p:txBody>
-          <a:bodyPr xmlns:a="http://schemas.openxmlformats.org/drawingml/2006/main" lIns="0" tIns="0" rIns="0" bIns="0" anchor="t"/>
-          <a:lstStyle xmlns:a="http://schemas.openxmlformats.org/drawingml/2006/main"/>
-          <a:p xmlns:a="http://schemas.openxmlformats.org/drawingml/2006/main">
+          <a:bodyPr lIns="0" tIns="0" rIns="0" bIns="0" anchor="t"/>
+          <a:lstStyle/>
+          <a:p>
             <a:pPr algn="l">
               <a:defRPr sz="2400" b="1">
                 <a:solidFill>
@@ -8920,7 +8961,7 @@
                   <a:srgbClr val="172026"/>
                 </a:solidFill>
               </a:rPr>
-              <a:t>設計模式 2 - Factory Pattern</a:t>
+              <a:t>設計模式 2 - Template Method Pattern</a:t>
             </a:r>
           </a:p>
         </p:txBody>
@@ -8928,31 +8969,31 @@
       <p:sp>
         <p:nvSpPr>
           <p:cNvPr id="7" name="">
-            <a:extLst xmlns:a="http://schemas.openxmlformats.org/drawingml/2006/main">
-              <a:ext uri="{FF2B5EF4-FFF2-40B4-BE49-F238E27FC236}">
-                <a16:creationId xmlns:a16="http://schemas.microsoft.com/office/drawing/2014/main" id="{25435270-FA93-4477-9F64-8E1780E9F60D}"/>
-              </a:ext>
-            </a:extLst>
-          </p:cNvPr>
-          <p:cNvSpPr>
-            <a:spLocks xmlns:a="http://schemas.openxmlformats.org/drawingml/2006/main" noGrp="1"/>
-          </p:cNvSpPr>
-          <p:nvPr/>
-        </p:nvSpPr>
-        <p:spPr>
-          <a:xfrm xmlns:a="http://schemas.openxmlformats.org/drawingml/2006/main" rot="0">
+            <a:extLst>
+              <a:ext uri="{FF2B5EF4-FFF2-40B4-BE49-F238E27FC236}">
+                <ns2:creationId id="{25435270-FA93-4477-9F64-8E1780E9F60D}"/>
+              </a:ext>
+            </a:extLst>
+          </p:cNvPr>
+          <p:cNvSpPr>
+            <a:spLocks noGrp="1"/>
+          </p:cNvSpPr>
+          <p:nvPr/>
+        </p:nvSpPr>
+        <p:spPr>
+          <a:xfrm rot="0">
             <a:off x="628650" y="1257300"/>
             <a:ext cx="9334500" cy="400050"/>
           </a:xfrm>
-          <a:prstGeom xmlns:a="http://schemas.openxmlformats.org/drawingml/2006/main" prst="rect">
-            <a:avLst/>
-          </a:prstGeom>
-          <a:solidFill xmlns:a="http://schemas.openxmlformats.org/drawingml/2006/main">
+          <a:prstGeom prst="rect">
+            <a:avLst/>
+          </a:prstGeom>
+          <a:solidFill>
             <a:srgbClr val="000000">
               <a:alpha val="0"/>
             </a:srgbClr>
           </a:solidFill>
-          <a:ln xmlns:a="http://schemas.openxmlformats.org/drawingml/2006/main" w="0">
+          <a:ln w="0">
             <a:solidFill>
               <a:srgbClr val="000000">
                 <a:alpha val="0"/>
@@ -8962,9 +9003,9 @@
           </a:ln>
         </p:spPr>
         <p:txBody>
-          <a:bodyPr xmlns:a="http://schemas.openxmlformats.org/drawingml/2006/main" lIns="0" tIns="0" rIns="0" bIns="0" anchor="t"/>
-          <a:lstStyle xmlns:a="http://schemas.openxmlformats.org/drawingml/2006/main"/>
-          <a:p xmlns:a="http://schemas.openxmlformats.org/drawingml/2006/main">
+          <a:bodyPr lIns="0" tIns="0" rIns="0" bIns="0" anchor="t"/>
+          <a:lstStyle/>
+          <a:p>
             <a:pPr algn="l">
               <a:defRPr sz="1200" b="0">
                 <a:solidFill>
@@ -8978,7 +9019,7 @@
                   <a:srgbClr val="4F5B66"/>
                 </a:solidFill>
               </a:rPr>
-              <a:t>設計模式必須對專題有實際作用，而不是只在理論上提到。</a:t>
+              <a:t>用 AlertRule 說明：父類別固定通知流程，子類別補上可變步驟。</a:t>
             </a:r>
           </a:p>
         </p:txBody>
@@ -8986,31 +9027,31 @@
       <p:sp>
         <p:nvSpPr>
           <p:cNvPr id="8" name="">
-            <a:extLst xmlns:a="http://schemas.openxmlformats.org/drawingml/2006/main">
-              <a:ext uri="{FF2B5EF4-FFF2-40B4-BE49-F238E27FC236}">
-                <a16:creationId xmlns:a16="http://schemas.microsoft.com/office/drawing/2014/main" id="{9CADA108-9B83-4FBC-A24D-9A36AB1715B9}"/>
-              </a:ext>
-            </a:extLst>
-          </p:cNvPr>
-          <p:cNvSpPr>
-            <a:spLocks xmlns:a="http://schemas.openxmlformats.org/drawingml/2006/main" noGrp="1"/>
-          </p:cNvSpPr>
-          <p:nvPr/>
-        </p:nvSpPr>
-        <p:spPr>
-          <a:xfrm xmlns:a="http://schemas.openxmlformats.org/drawingml/2006/main" rot="0">
+            <a:extLst>
+              <a:ext uri="{FF2B5EF4-FFF2-40B4-BE49-F238E27FC236}">
+                <ns2:creationId id="{9CADA108-9B83-4FBC-A24D-9A36AB1715B9}"/>
+              </a:ext>
+            </a:extLst>
+          </p:cNvPr>
+          <p:cNvSpPr>
+            <a:spLocks noGrp="1"/>
+          </p:cNvSpPr>
+          <p:nvPr/>
+        </p:nvSpPr>
+        <p:spPr>
+          <a:xfrm rot="0">
             <a:off x="609600" y="1866900"/>
             <a:ext cx="3143250" cy="3790950"/>
           </a:xfrm>
-          <a:prstGeom xmlns:a="http://schemas.openxmlformats.org/drawingml/2006/main" prst="roundRect">
+          <a:prstGeom prst="roundRect">
             <a:avLst>
               <a:gd name="adj" fmla="val 2424"/>
             </a:avLst>
           </a:prstGeom>
-          <a:solidFill xmlns:a="http://schemas.openxmlformats.org/drawingml/2006/main">
+          <a:solidFill>
             <a:srgbClr val="FFFDF8"/>
           </a:solidFill>
-          <a:ln xmlns:a="http://schemas.openxmlformats.org/drawingml/2006/main" w="11430">
+          <a:ln w="11430">
             <a:solidFill>
               <a:srgbClr val="23313B"/>
             </a:solidFill>
@@ -9021,29 +9062,29 @@
       <p:sp>
         <p:nvSpPr>
           <p:cNvPr id="9" name="">
-            <a:extLst xmlns:a="http://schemas.openxmlformats.org/drawingml/2006/main">
-              <a:ext uri="{FF2B5EF4-FFF2-40B4-BE49-F238E27FC236}">
-                <a16:creationId xmlns:a16="http://schemas.microsoft.com/office/drawing/2014/main" id="{D87C1353-F658-40A2-860E-8D09D0B1DCD6}"/>
-              </a:ext>
-            </a:extLst>
-          </p:cNvPr>
-          <p:cNvSpPr>
-            <a:spLocks xmlns:a="http://schemas.openxmlformats.org/drawingml/2006/main" noGrp="1"/>
-          </p:cNvSpPr>
-          <p:nvPr/>
-        </p:nvSpPr>
-        <p:spPr>
-          <a:xfrm xmlns:a="http://schemas.openxmlformats.org/drawingml/2006/main" rot="0">
+            <a:extLst>
+              <a:ext uri="{FF2B5EF4-FFF2-40B4-BE49-F238E27FC236}">
+                <ns2:creationId id="{D87C1353-F658-40A2-860E-8D09D0B1DCD6}"/>
+              </a:ext>
+            </a:extLst>
+          </p:cNvPr>
+          <p:cNvSpPr>
+            <a:spLocks noGrp="1"/>
+          </p:cNvSpPr>
+          <p:nvPr/>
+        </p:nvSpPr>
+        <p:spPr>
+          <a:xfrm rot="0">
             <a:off x="609600" y="1866900"/>
             <a:ext cx="3143250" cy="76200"/>
           </a:xfrm>
-          <a:prstGeom xmlns:a="http://schemas.openxmlformats.org/drawingml/2006/main" prst="rect">
-            <a:avLst/>
-          </a:prstGeom>
-          <a:solidFill xmlns:a="http://schemas.openxmlformats.org/drawingml/2006/main">
+          <a:prstGeom prst="rect">
+            <a:avLst/>
+          </a:prstGeom>
+          <a:solidFill>
             <a:srgbClr val="E57B62"/>
           </a:solidFill>
-          <a:ln xmlns:a="http://schemas.openxmlformats.org/drawingml/2006/main" w="0">
+          <a:ln w="0">
             <a:solidFill>
               <a:srgbClr val="000000">
                 <a:alpha val="0"/>
@@ -9056,31 +9097,31 @@
       <p:sp>
         <p:nvSpPr>
           <p:cNvPr id="10" name="">
-            <a:extLst xmlns:a="http://schemas.openxmlformats.org/drawingml/2006/main">
-              <a:ext uri="{FF2B5EF4-FFF2-40B4-BE49-F238E27FC236}">
-                <a16:creationId xmlns:a16="http://schemas.microsoft.com/office/drawing/2014/main" id="{3B844A5A-8EDE-4029-9D87-AB5F53CEF05C}"/>
-              </a:ext>
-            </a:extLst>
-          </p:cNvPr>
-          <p:cNvSpPr>
-            <a:spLocks xmlns:a="http://schemas.openxmlformats.org/drawingml/2006/main" noGrp="1"/>
-          </p:cNvSpPr>
-          <p:nvPr/>
-        </p:nvSpPr>
-        <p:spPr>
-          <a:xfrm xmlns:a="http://schemas.openxmlformats.org/drawingml/2006/main" rot="0">
+            <a:extLst>
+              <a:ext uri="{FF2B5EF4-FFF2-40B4-BE49-F238E27FC236}">
+                <ns2:creationId id="{3B844A5A-8EDE-4029-9D87-AB5F53CEF05C}"/>
+              </a:ext>
+            </a:extLst>
+          </p:cNvPr>
+          <p:cNvSpPr>
+            <a:spLocks noGrp="1"/>
+          </p:cNvSpPr>
+          <p:nvPr/>
+        </p:nvSpPr>
+        <p:spPr>
+          <a:xfrm rot="0">
             <a:off x="800100" y="2038350"/>
             <a:ext cx="2762250" cy="266700"/>
           </a:xfrm>
-          <a:prstGeom xmlns:a="http://schemas.openxmlformats.org/drawingml/2006/main" prst="rect">
-            <a:avLst/>
-          </a:prstGeom>
-          <a:solidFill xmlns:a="http://schemas.openxmlformats.org/drawingml/2006/main">
+          <a:prstGeom prst="rect">
+            <a:avLst/>
+          </a:prstGeom>
+          <a:solidFill>
             <a:srgbClr val="000000">
               <a:alpha val="0"/>
             </a:srgbClr>
           </a:solidFill>
-          <a:ln xmlns:a="http://schemas.openxmlformats.org/drawingml/2006/main" w="0">
+          <a:ln w="0">
             <a:solidFill>
               <a:srgbClr val="000000">
                 <a:alpha val="0"/>
@@ -9090,9 +9131,9 @@
           </a:ln>
         </p:spPr>
         <p:txBody>
-          <a:bodyPr xmlns:a="http://schemas.openxmlformats.org/drawingml/2006/main" lIns="0" tIns="0" rIns="0" bIns="0" anchor="t"/>
-          <a:lstStyle xmlns:a="http://schemas.openxmlformats.org/drawingml/2006/main"/>
-          <a:p xmlns:a="http://schemas.openxmlformats.org/drawingml/2006/main">
+          <a:bodyPr lIns="0" tIns="0" rIns="0" bIns="0" anchor="t"/>
+          <a:lstStyle/>
+          <a:p>
             <a:pPr algn="l">
               <a:defRPr sz="1350" b="1">
                 <a:solidFill>
@@ -9114,31 +9155,31 @@
       <p:sp>
         <p:nvSpPr>
           <p:cNvPr id="11" name="">
-            <a:extLst xmlns:a="http://schemas.openxmlformats.org/drawingml/2006/main">
-              <a:ext uri="{FF2B5EF4-FFF2-40B4-BE49-F238E27FC236}">
-                <a16:creationId xmlns:a16="http://schemas.microsoft.com/office/drawing/2014/main" id="{5344813E-6AB7-4F14-9F8A-733C5027B82C}"/>
-              </a:ext>
-            </a:extLst>
-          </p:cNvPr>
-          <p:cNvSpPr>
-            <a:spLocks xmlns:a="http://schemas.openxmlformats.org/drawingml/2006/main" noGrp="1"/>
-          </p:cNvSpPr>
-          <p:nvPr/>
-        </p:nvSpPr>
-        <p:spPr>
-          <a:xfrm xmlns:a="http://schemas.openxmlformats.org/drawingml/2006/main" rot="0">
+            <a:extLst>
+              <a:ext uri="{FF2B5EF4-FFF2-40B4-BE49-F238E27FC236}">
+                <ns2:creationId id="{5344813E-6AB7-4F14-9F8A-733C5027B82C}"/>
+              </a:ext>
+            </a:extLst>
+          </p:cNvPr>
+          <p:cNvSpPr>
+            <a:spLocks noGrp="1"/>
+          </p:cNvSpPr>
+          <p:nvPr/>
+        </p:nvSpPr>
+        <p:spPr>
+          <a:xfrm rot="0">
             <a:off x="857250" y="2400300"/>
             <a:ext cx="2647950" cy="1657350"/>
           </a:xfrm>
-          <a:prstGeom xmlns:a="http://schemas.openxmlformats.org/drawingml/2006/main" prst="rect">
-            <a:avLst/>
-          </a:prstGeom>
-          <a:solidFill xmlns:a="http://schemas.openxmlformats.org/drawingml/2006/main">
+          <a:prstGeom prst="rect">
+            <a:avLst/>
+          </a:prstGeom>
+          <a:solidFill>
             <a:srgbClr val="000000">
               <a:alpha val="0"/>
             </a:srgbClr>
           </a:solidFill>
-          <a:ln xmlns:a="http://schemas.openxmlformats.org/drawingml/2006/main" w="0">
+          <a:ln w="0">
             <a:solidFill>
               <a:srgbClr val="000000">
                 <a:alpha val="0"/>
@@ -9148,9 +9189,9 @@
           </a:ln>
         </p:spPr>
         <p:txBody>
-          <a:bodyPr xmlns:a="http://schemas.openxmlformats.org/drawingml/2006/main" lIns="0" tIns="0" rIns="0" bIns="0" anchor="t"/>
-          <a:lstStyle xmlns:a="http://schemas.openxmlformats.org/drawingml/2006/main"/>
-          <a:p xmlns:a="http://schemas.openxmlformats.org/drawingml/2006/main">
+          <a:bodyPr lIns="0" tIns="0" rIns="0" bIns="0" anchor="t"/>
+          <a:lstStyle/>
+          <a:p>
             <a:pPr algn="l">
               <a:defRPr sz="1275" b="0">
                 <a:solidFill>
@@ -9164,15 +9205,27 @@
                   <a:srgbClr val="172026"/>
                 </a:solidFill>
               </a:rPr>
-              <a:t>集中物件建立邏輯，讓上層不直接依賴具體類別。</a:t>
-            </a:r>
-          </a:p>
-          <a:p xmlns:a="http://schemas.openxmlformats.org/drawingml/2006/main">
-            <a:r>
+              <a:t>父類別定義演算法骨架，並在固定流程中呼叫由子類別實作的步驟。</a:t>
+            </a:r>
+          </a:p>
+          <a:p>
+            <a:pPr algn="l">
+              <a:defRPr sz="1275" b="0">
+                <a:solidFill>
+                  <a:srgbClr val="172026"/>
+                </a:solidFill>
+              </a:defRPr>
+            </a:pPr>
+            <a:r>
+              <a:rPr sz="1275" b="0">
+                <a:solidFill>
+                  <a:srgbClr val="172026"/>
+                </a:solidFill>
+              </a:rPr>
               <a:t/>
             </a:r>
           </a:p>
-          <a:p xmlns:a="http://schemas.openxmlformats.org/drawingml/2006/main">
+          <a:p>
             <a:pPr algn="l">
               <a:defRPr sz="1275" b="0">
                 <a:solidFill>
@@ -9186,7 +9239,7 @@
                   <a:srgbClr val="172026"/>
                 </a:solidFill>
               </a:rPr>
-              <a:t>API layer 不應該自己判斷要建立哪一種具體警示規則物件。</a:t>
+              <a:t>AlertRule.buildNotification() 固定通知格式，但條件文字由 getConditionLabel() 決定。</a:t>
             </a:r>
           </a:p>
         </p:txBody>
@@ -9194,31 +9247,31 @@
       <p:sp>
         <p:nvSpPr>
           <p:cNvPr id="12" name="">
-            <a:extLst xmlns:a="http://schemas.openxmlformats.org/drawingml/2006/main">
-              <a:ext uri="{FF2B5EF4-FFF2-40B4-BE49-F238E27FC236}">
-                <a16:creationId xmlns:a16="http://schemas.microsoft.com/office/drawing/2014/main" id="{B71D6A12-DB77-4686-87FE-48B2698A49B9}"/>
-              </a:ext>
-            </a:extLst>
-          </p:cNvPr>
-          <p:cNvSpPr>
-            <a:spLocks xmlns:a="http://schemas.openxmlformats.org/drawingml/2006/main" noGrp="1"/>
-          </p:cNvSpPr>
-          <p:nvPr/>
-        </p:nvSpPr>
-        <p:spPr>
-          <a:xfrm xmlns:a="http://schemas.openxmlformats.org/drawingml/2006/main" rot="0">
+            <a:extLst>
+              <a:ext uri="{FF2B5EF4-FFF2-40B4-BE49-F238E27FC236}">
+                <ns2:creationId id="{B71D6A12-DB77-4686-87FE-48B2698A49B9}"/>
+              </a:ext>
+            </a:extLst>
+          </p:cNvPr>
+          <p:cNvSpPr>
+            <a:spLocks noGrp="1"/>
+          </p:cNvSpPr>
+          <p:nvPr/>
+        </p:nvSpPr>
+        <p:spPr>
+          <a:xfrm rot="0">
             <a:off x="4514850" y="1866900"/>
             <a:ext cx="3295650" cy="3790950"/>
           </a:xfrm>
-          <a:prstGeom xmlns:a="http://schemas.openxmlformats.org/drawingml/2006/main" prst="roundRect">
+          <a:prstGeom prst="roundRect">
             <a:avLst>
               <a:gd name="adj" fmla="val 2312"/>
             </a:avLst>
           </a:prstGeom>
-          <a:solidFill xmlns:a="http://schemas.openxmlformats.org/drawingml/2006/main">
+          <a:solidFill>
             <a:srgbClr val="FFFDF8"/>
           </a:solidFill>
-          <a:ln xmlns:a="http://schemas.openxmlformats.org/drawingml/2006/main" w="11430">
+          <a:ln w="11430">
             <a:solidFill>
               <a:srgbClr val="23313B"/>
             </a:solidFill>
@@ -9229,29 +9282,29 @@
       <p:sp>
         <p:nvSpPr>
           <p:cNvPr id="13" name="">
-            <a:extLst xmlns:a="http://schemas.openxmlformats.org/drawingml/2006/main">
-              <a:ext uri="{FF2B5EF4-FFF2-40B4-BE49-F238E27FC236}">
-                <a16:creationId xmlns:a16="http://schemas.microsoft.com/office/drawing/2014/main" id="{945D8EA9-6A57-43B6-AC52-6B509CF56125}"/>
-              </a:ext>
-            </a:extLst>
-          </p:cNvPr>
-          <p:cNvSpPr>
-            <a:spLocks xmlns:a="http://schemas.openxmlformats.org/drawingml/2006/main" noGrp="1"/>
-          </p:cNvSpPr>
-          <p:nvPr/>
-        </p:nvSpPr>
-        <p:spPr>
-          <a:xfrm xmlns:a="http://schemas.openxmlformats.org/drawingml/2006/main" rot="0">
+            <a:extLst>
+              <a:ext uri="{FF2B5EF4-FFF2-40B4-BE49-F238E27FC236}">
+                <ns2:creationId id="{945D8EA9-6A57-43B6-AC52-6B509CF56125}"/>
+              </a:ext>
+            </a:extLst>
+          </p:cNvPr>
+          <p:cNvSpPr>
+            <a:spLocks noGrp="1"/>
+          </p:cNvSpPr>
+          <p:nvPr/>
+        </p:nvSpPr>
+        <p:spPr>
+          <a:xfrm rot="0">
             <a:off x="4514850" y="1866900"/>
             <a:ext cx="3295650" cy="76200"/>
           </a:xfrm>
-          <a:prstGeom xmlns:a="http://schemas.openxmlformats.org/drawingml/2006/main" prst="rect">
-            <a:avLst/>
-          </a:prstGeom>
-          <a:solidFill xmlns:a="http://schemas.openxmlformats.org/drawingml/2006/main">
+          <a:prstGeom prst="rect">
+            <a:avLst/>
+          </a:prstGeom>
+          <a:solidFill>
             <a:srgbClr val="38B58A"/>
           </a:solidFill>
-          <a:ln xmlns:a="http://schemas.openxmlformats.org/drawingml/2006/main" w="0">
+          <a:ln w="0">
             <a:solidFill>
               <a:srgbClr val="000000">
                 <a:alpha val="0"/>
@@ -9264,31 +9317,31 @@
       <p:sp>
         <p:nvSpPr>
           <p:cNvPr id="14" name="">
-            <a:extLst xmlns:a="http://schemas.openxmlformats.org/drawingml/2006/main">
-              <a:ext uri="{FF2B5EF4-FFF2-40B4-BE49-F238E27FC236}">
-                <a16:creationId xmlns:a16="http://schemas.microsoft.com/office/drawing/2014/main" id="{983EA221-38A5-4948-843B-BF1F168B4EB3}"/>
-              </a:ext>
-            </a:extLst>
-          </p:cNvPr>
-          <p:cNvSpPr>
-            <a:spLocks xmlns:a="http://schemas.openxmlformats.org/drawingml/2006/main" noGrp="1"/>
-          </p:cNvSpPr>
-          <p:nvPr/>
-        </p:nvSpPr>
-        <p:spPr>
-          <a:xfrm xmlns:a="http://schemas.openxmlformats.org/drawingml/2006/main" rot="0">
+            <a:extLst>
+              <a:ext uri="{FF2B5EF4-FFF2-40B4-BE49-F238E27FC236}">
+                <ns2:creationId id="{983EA221-38A5-4948-843B-BF1F168B4EB3}"/>
+              </a:ext>
+            </a:extLst>
+          </p:cNvPr>
+          <p:cNvSpPr>
+            <a:spLocks noGrp="1"/>
+          </p:cNvSpPr>
+          <p:nvPr/>
+        </p:nvSpPr>
+        <p:spPr>
+          <a:xfrm rot="0">
             <a:off x="4705350" y="2038350"/>
             <a:ext cx="2914650" cy="266700"/>
           </a:xfrm>
-          <a:prstGeom xmlns:a="http://schemas.openxmlformats.org/drawingml/2006/main" prst="rect">
-            <a:avLst/>
-          </a:prstGeom>
-          <a:solidFill xmlns:a="http://schemas.openxmlformats.org/drawingml/2006/main">
+          <a:prstGeom prst="rect">
+            <a:avLst/>
+          </a:prstGeom>
+          <a:solidFill>
             <a:srgbClr val="000000">
               <a:alpha val="0"/>
             </a:srgbClr>
           </a:solidFill>
-          <a:ln xmlns:a="http://schemas.openxmlformats.org/drawingml/2006/main" w="0">
+          <a:ln w="0">
             <a:solidFill>
               <a:srgbClr val="000000">
                 <a:alpha val="0"/>
@@ -9298,9 +9351,9 @@
           </a:ln>
         </p:spPr>
         <p:txBody>
-          <a:bodyPr xmlns:a="http://schemas.openxmlformats.org/drawingml/2006/main" lIns="0" tIns="0" rIns="0" bIns="0" anchor="t"/>
-          <a:lstStyle xmlns:a="http://schemas.openxmlformats.org/drawingml/2006/main"/>
-          <a:p xmlns:a="http://schemas.openxmlformats.org/drawingml/2006/main">
+          <a:bodyPr lIns="0" tIns="0" rIns="0" bIns="0" anchor="t"/>
+          <a:lstStyle/>
+          <a:p>
             <a:pPr algn="l">
               <a:defRPr sz="1350" b="1">
                 <a:solidFill>
@@ -9322,31 +9375,31 @@
       <p:sp>
         <p:nvSpPr>
           <p:cNvPr id="15" name="">
-            <a:extLst xmlns:a="http://schemas.openxmlformats.org/drawingml/2006/main">
-              <a:ext uri="{FF2B5EF4-FFF2-40B4-BE49-F238E27FC236}">
-                <a16:creationId xmlns:a16="http://schemas.microsoft.com/office/drawing/2014/main" id="{9D8A6B41-5336-4FBB-A464-33959291A629}"/>
-              </a:ext>
-            </a:extLst>
-          </p:cNvPr>
-          <p:cNvSpPr>
-            <a:spLocks xmlns:a="http://schemas.openxmlformats.org/drawingml/2006/main" noGrp="1"/>
-          </p:cNvSpPr>
-          <p:nvPr/>
-        </p:nvSpPr>
-        <p:spPr>
-          <a:xfrm xmlns:a="http://schemas.openxmlformats.org/drawingml/2006/main" rot="0">
+            <a:extLst>
+              <a:ext uri="{FF2B5EF4-FFF2-40B4-BE49-F238E27FC236}">
+                <ns2:creationId id="{9D8A6B41-5336-4FBB-A464-33959291A629}"/>
+              </a:ext>
+            </a:extLst>
+          </p:cNvPr>
+          <p:cNvSpPr>
+            <a:spLocks noGrp="1"/>
+          </p:cNvSpPr>
+          <p:nvPr/>
+        </p:nvSpPr>
+        <p:spPr>
+          <a:xfrm rot="0">
             <a:off x="4762500" y="2400300"/>
             <a:ext cx="2800350" cy="1771650"/>
           </a:xfrm>
-          <a:prstGeom xmlns:a="http://schemas.openxmlformats.org/drawingml/2006/main" prst="rect">
-            <a:avLst/>
-          </a:prstGeom>
-          <a:solidFill xmlns:a="http://schemas.openxmlformats.org/drawingml/2006/main">
+          <a:prstGeom prst="rect">
+            <a:avLst/>
+          </a:prstGeom>
+          <a:solidFill>
             <a:srgbClr val="000000">
               <a:alpha val="0"/>
             </a:srgbClr>
           </a:solidFill>
-          <a:ln xmlns:a="http://schemas.openxmlformats.org/drawingml/2006/main" w="0">
+          <a:ln w="0">
             <a:solidFill>
               <a:srgbClr val="000000">
                 <a:alpha val="0"/>
@@ -9356,9 +9409,9 @@
           </a:ln>
         </p:spPr>
         <p:txBody>
-          <a:bodyPr xmlns:a="http://schemas.openxmlformats.org/drawingml/2006/main" lIns="0" tIns="0" rIns="0" bIns="0" anchor="t"/>
-          <a:lstStyle xmlns:a="http://schemas.openxmlformats.org/drawingml/2006/main"/>
-          <a:p xmlns:a="http://schemas.openxmlformats.org/drawingml/2006/main">
+          <a:bodyPr lIns="0" tIns="0" rIns="0" bIns="0" anchor="t"/>
+          <a:lstStyle/>
+          <a:p>
             <a:pPr algn="l">
               <a:defRPr sz="1275" b="0">
                 <a:solidFill>
@@ -9372,15 +9425,44 @@
                   <a:srgbClr val="172026"/>
                 </a:solidFill>
               </a:rPr>
-              <a:t>Function: createAlertRule(...)</a:t>
-            </a:r>
-          </a:p>
-          <a:p xmlns:a="http://schemas.openxmlformats.org/drawingml/2006/main">
-            <a:r>
+              <a:t>主要 class 對應</a:t>
+            </a:r>
+          </a:p>
+          <a:p>
+            <a:pPr algn="l">
+              <a:defRPr sz="1275" b="0">
+                <a:solidFill>
+                  <a:srgbClr val="172026"/>
+                </a:solidFill>
+              </a:defRPr>
+            </a:pPr>
+            <a:r>
+              <a:rPr sz="1275" b="0">
+                <a:solidFill>
+                  <a:srgbClr val="172026"/>
+                </a:solidFill>
+              </a:rPr>
+              <a:t>AlertRule：提供 buildNotification(snapshot) 通知產生流程</a:t>
+            </a:r>
+          </a:p>
+          <a:p>
+            <a:pPr algn="l">
+              <a:defRPr sz="1275" b="0">
+                <a:solidFill>
+                  <a:srgbClr val="172026"/>
+                </a:solidFill>
+              </a:defRPr>
+            </a:pPr>
+            <a:r>
+              <a:rPr sz="1275" b="0">
+                <a:solidFill>
+                  <a:srgbClr val="172026"/>
+                </a:solidFill>
+              </a:rPr>
               <a:t/>
             </a:r>
           </a:p>
-          <a:p xmlns:a="http://schemas.openxmlformats.org/drawingml/2006/main">
+          <a:p>
             <a:pPr algn="l">
               <a:defRPr sz="1275" b="0">
                 <a:solidFill>
@@ -9394,10 +9476,10 @@
                   <a:srgbClr val="172026"/>
                 </a:solidFill>
               </a:rPr>
-              <a:t>Input: 資料庫中的 alert rule record</a:t>
-            </a:r>
-          </a:p>
-          <a:p xmlns:a="http://schemas.openxmlformats.org/drawingml/2006/main">
+              <a:t>子類別：PriceAboveAlertRule / PriceBelowAlertRule</a:t>
+            </a:r>
+          </a:p>
+          <a:p>
             <a:pPr algn="l">
               <a:defRPr sz="1275" b="0">
                 <a:solidFill>
@@ -9411,15 +9493,10 @@
                   <a:srgbClr val="172026"/>
                 </a:solidFill>
               </a:rPr>
-              <a:t>Output: 具體 AlertRule object</a:t>
-            </a:r>
-          </a:p>
-          <a:p xmlns:a="http://schemas.openxmlformats.org/drawingml/2006/main">
-            <a:r>
               <a:t/>
             </a:r>
           </a:p>
-          <a:p xmlns:a="http://schemas.openxmlformats.org/drawingml/2006/main">
+          <a:p>
             <a:pPr algn="l">
               <a:defRPr sz="1275" b="0">
                 <a:solidFill>
@@ -9433,7 +9510,7 @@
                   <a:srgbClr val="172026"/>
                 </a:solidFill>
               </a:rPr>
-              <a:t>在評估前，先把儲存設定轉成可執行的 domain object。</a:t>
+              <a:t>可變步驟：各自實作 getConditionLabel() 與 isTriggered(snapshot)</a:t>
             </a:r>
           </a:p>
         </p:txBody>
@@ -9441,31 +9518,31 @@
       <p:sp>
         <p:nvSpPr>
           <p:cNvPr id="16" name="">
-            <a:extLst xmlns:a="http://schemas.openxmlformats.org/drawingml/2006/main">
-              <a:ext uri="{FF2B5EF4-FFF2-40B4-BE49-F238E27FC236}">
-                <a16:creationId xmlns:a16="http://schemas.microsoft.com/office/drawing/2014/main" id="{B7FA66B7-A58B-4B6C-A65D-BA8D0B277C75}"/>
-              </a:ext>
-            </a:extLst>
-          </p:cNvPr>
-          <p:cNvSpPr>
-            <a:spLocks xmlns:a="http://schemas.openxmlformats.org/drawingml/2006/main" noGrp="1"/>
-          </p:cNvSpPr>
-          <p:nvPr/>
-        </p:nvSpPr>
-        <p:spPr>
-          <a:xfrm xmlns:a="http://schemas.openxmlformats.org/drawingml/2006/main" rot="0">
+            <a:extLst>
+              <a:ext uri="{FF2B5EF4-FFF2-40B4-BE49-F238E27FC236}">
+                <ns2:creationId id="{B7FA66B7-A58B-4B6C-A65D-BA8D0B277C75}"/>
+              </a:ext>
+            </a:extLst>
+          </p:cNvPr>
+          <p:cNvSpPr>
+            <a:spLocks noGrp="1"/>
+          </p:cNvSpPr>
+          <p:nvPr/>
+        </p:nvSpPr>
+        <p:spPr>
+          <a:xfrm rot="0">
             <a:off x="8572500" y="1866900"/>
             <a:ext cx="3009900" cy="3790950"/>
           </a:xfrm>
-          <a:prstGeom xmlns:a="http://schemas.openxmlformats.org/drawingml/2006/main" prst="roundRect">
+          <a:prstGeom prst="roundRect">
             <a:avLst>
               <a:gd name="adj" fmla="val 2532"/>
             </a:avLst>
           </a:prstGeom>
-          <a:solidFill xmlns:a="http://schemas.openxmlformats.org/drawingml/2006/main">
+          <a:solidFill>
             <a:srgbClr val="FFFDF8"/>
           </a:solidFill>
-          <a:ln xmlns:a="http://schemas.openxmlformats.org/drawingml/2006/main" w="11430">
+          <a:ln w="11430">
             <a:solidFill>
               <a:srgbClr val="23313B"/>
             </a:solidFill>
@@ -9476,29 +9553,29 @@
       <p:sp>
         <p:nvSpPr>
           <p:cNvPr id="17" name="">
-            <a:extLst xmlns:a="http://schemas.openxmlformats.org/drawingml/2006/main">
-              <a:ext uri="{FF2B5EF4-FFF2-40B4-BE49-F238E27FC236}">
-                <a16:creationId xmlns:a16="http://schemas.microsoft.com/office/drawing/2014/main" id="{134BDC0C-1929-4BEB-8CF8-EF486219E46A}"/>
-              </a:ext>
-            </a:extLst>
-          </p:cNvPr>
-          <p:cNvSpPr>
-            <a:spLocks xmlns:a="http://schemas.openxmlformats.org/drawingml/2006/main" noGrp="1"/>
-          </p:cNvSpPr>
-          <p:nvPr/>
-        </p:nvSpPr>
-        <p:spPr>
-          <a:xfrm xmlns:a="http://schemas.openxmlformats.org/drawingml/2006/main" rot="0">
+            <a:extLst>
+              <a:ext uri="{FF2B5EF4-FFF2-40B4-BE49-F238E27FC236}">
+                <ns2:creationId id="{134BDC0C-1929-4BEB-8CF8-EF486219E46A}"/>
+              </a:ext>
+            </a:extLst>
+          </p:cNvPr>
+          <p:cNvSpPr>
+            <a:spLocks noGrp="1"/>
+          </p:cNvSpPr>
+          <p:nvPr/>
+        </p:nvSpPr>
+        <p:spPr>
+          <a:xfrm rot="0">
             <a:off x="8572500" y="1866900"/>
             <a:ext cx="3009900" cy="76200"/>
           </a:xfrm>
-          <a:prstGeom xmlns:a="http://schemas.openxmlformats.org/drawingml/2006/main" prst="rect">
-            <a:avLst/>
-          </a:prstGeom>
-          <a:solidFill xmlns:a="http://schemas.openxmlformats.org/drawingml/2006/main">
+          <a:prstGeom prst="rect">
+            <a:avLst/>
+          </a:prstGeom>
+          <a:solidFill>
             <a:srgbClr val="D6A04B"/>
           </a:solidFill>
-          <a:ln xmlns:a="http://schemas.openxmlformats.org/drawingml/2006/main" w="0">
+          <a:ln w="0">
             <a:solidFill>
               <a:srgbClr val="000000">
                 <a:alpha val="0"/>
@@ -9511,31 +9588,31 @@
       <p:sp>
         <p:nvSpPr>
           <p:cNvPr id="18" name="">
-            <a:extLst xmlns:a="http://schemas.openxmlformats.org/drawingml/2006/main">
-              <a:ext uri="{FF2B5EF4-FFF2-40B4-BE49-F238E27FC236}">
-                <a16:creationId xmlns:a16="http://schemas.microsoft.com/office/drawing/2014/main" id="{19DADF23-1C3D-4264-9B5A-54015CB62A2D}"/>
-              </a:ext>
-            </a:extLst>
-          </p:cNvPr>
-          <p:cNvSpPr>
-            <a:spLocks xmlns:a="http://schemas.openxmlformats.org/drawingml/2006/main" noGrp="1"/>
-          </p:cNvSpPr>
-          <p:nvPr/>
-        </p:nvSpPr>
-        <p:spPr>
-          <a:xfrm xmlns:a="http://schemas.openxmlformats.org/drawingml/2006/main" rot="0">
+            <a:extLst>
+              <a:ext uri="{FF2B5EF4-FFF2-40B4-BE49-F238E27FC236}">
+                <ns2:creationId id="{19DADF23-1C3D-4264-9B5A-54015CB62A2D}"/>
+              </a:ext>
+            </a:extLst>
+          </p:cNvPr>
+          <p:cNvSpPr>
+            <a:spLocks noGrp="1"/>
+          </p:cNvSpPr>
+          <p:nvPr/>
+        </p:nvSpPr>
+        <p:spPr>
+          <a:xfrm rot="0">
             <a:off x="8763000" y="2038350"/>
             <a:ext cx="2628900" cy="266700"/>
           </a:xfrm>
-          <a:prstGeom xmlns:a="http://schemas.openxmlformats.org/drawingml/2006/main" prst="rect">
-            <a:avLst/>
-          </a:prstGeom>
-          <a:solidFill xmlns:a="http://schemas.openxmlformats.org/drawingml/2006/main">
+          <a:prstGeom prst="rect">
+            <a:avLst/>
+          </a:prstGeom>
+          <a:solidFill>
             <a:srgbClr val="000000">
               <a:alpha val="0"/>
             </a:srgbClr>
           </a:solidFill>
-          <a:ln xmlns:a="http://schemas.openxmlformats.org/drawingml/2006/main" w="0">
+          <a:ln w="0">
             <a:solidFill>
               <a:srgbClr val="000000">
                 <a:alpha val="0"/>
@@ -9545,9 +9622,9 @@
           </a:ln>
         </p:spPr>
         <p:txBody>
-          <a:bodyPr xmlns:a="http://schemas.openxmlformats.org/drawingml/2006/main" lIns="0" tIns="0" rIns="0" bIns="0" anchor="t"/>
-          <a:lstStyle xmlns:a="http://schemas.openxmlformats.org/drawingml/2006/main"/>
-          <a:p xmlns:a="http://schemas.openxmlformats.org/drawingml/2006/main">
+          <a:bodyPr lIns="0" tIns="0" rIns="0" bIns="0" anchor="t"/>
+          <a:lstStyle/>
+          <a:p>
             <a:pPr algn="l">
               <a:defRPr sz="1350" b="1">
                 <a:solidFill>
@@ -9569,31 +9646,31 @@
       <p:sp>
         <p:nvSpPr>
           <p:cNvPr id="19" name="">
-            <a:extLst xmlns:a="http://schemas.openxmlformats.org/drawingml/2006/main">
-              <a:ext uri="{FF2B5EF4-FFF2-40B4-BE49-F238E27FC236}">
-                <a16:creationId xmlns:a16="http://schemas.microsoft.com/office/drawing/2014/main" id="{85F5B18F-F69C-4522-94D2-E6160700BE4C}"/>
-              </a:ext>
-            </a:extLst>
-          </p:cNvPr>
-          <p:cNvSpPr>
-            <a:spLocks xmlns:a="http://schemas.openxmlformats.org/drawingml/2006/main" noGrp="1"/>
-          </p:cNvSpPr>
-          <p:nvPr/>
-        </p:nvSpPr>
-        <p:spPr>
-          <a:xfrm xmlns:a="http://schemas.openxmlformats.org/drawingml/2006/main" rot="0">
+            <a:extLst>
+              <a:ext uri="{FF2B5EF4-FFF2-40B4-BE49-F238E27FC236}">
+                <ns2:creationId id="{85F5B18F-F69C-4522-94D2-E6160700BE4C}"/>
+              </a:ext>
+            </a:extLst>
+          </p:cNvPr>
+          <p:cNvSpPr>
+            <a:spLocks noGrp="1"/>
+          </p:cNvSpPr>
+          <p:nvPr/>
+        </p:nvSpPr>
+        <p:spPr>
+          <a:xfrm rot="0">
             <a:off x="8820150" y="2400300"/>
             <a:ext cx="2514600" cy="1790700"/>
           </a:xfrm>
-          <a:prstGeom xmlns:a="http://schemas.openxmlformats.org/drawingml/2006/main" prst="rect">
-            <a:avLst/>
-          </a:prstGeom>
-          <a:solidFill xmlns:a="http://schemas.openxmlformats.org/drawingml/2006/main">
+          <a:prstGeom prst="rect">
+            <a:avLst/>
+          </a:prstGeom>
+          <a:solidFill>
             <a:srgbClr val="000000">
               <a:alpha val="0"/>
             </a:srgbClr>
           </a:solidFill>
-          <a:ln xmlns:a="http://schemas.openxmlformats.org/drawingml/2006/main" w="0">
+          <a:ln w="0">
             <a:solidFill>
               <a:srgbClr val="000000">
                 <a:alpha val="0"/>
@@ -9603,9 +9680,9 @@
           </a:ln>
         </p:spPr>
         <p:txBody>
-          <a:bodyPr xmlns:a="http://schemas.openxmlformats.org/drawingml/2006/main" lIns="0" tIns="0" rIns="0" bIns="0" anchor="t"/>
-          <a:lstStyle xmlns:a="http://schemas.openxmlformats.org/drawingml/2006/main"/>
-          <a:p xmlns:a="http://schemas.openxmlformats.org/drawingml/2006/main">
+          <a:bodyPr lIns="0" tIns="0" rIns="0" bIns="0" anchor="t"/>
+          <a:lstStyle/>
+          <a:p>
             <a:pPr algn="l">
               <a:defRPr sz="1275" b="0">
                 <a:solidFill>
@@ -9619,10 +9696,10 @@
                   <a:srgbClr val="172026"/>
                 </a:solidFill>
               </a:rPr>
-              <a:t>1. API code 保持簡潔</a:t>
-            </a:r>
-          </a:p>
-          <a:p xmlns:a="http://schemas.openxmlformats.org/drawingml/2006/main">
+              <a:t>1. 通知格式集中在父類別</a:t>
+            </a:r>
+          </a:p>
+          <a:p>
             <a:pPr algn="l">
               <a:defRPr sz="1275" b="0">
                 <a:solidFill>
@@ -9636,10 +9713,10 @@
                   <a:srgbClr val="172026"/>
                 </a:solidFill>
               </a:rPr>
-              <a:t>2. 物件建立邏輯可重用</a:t>
-            </a:r>
-          </a:p>
-          <a:p xmlns:a="http://schemas.openxmlformats.org/drawingml/2006/main">
+              <a:t>2. 不同警示條件保留自己的判斷邏輯</a:t>
+            </a:r>
+          </a:p>
+          <a:p>
             <a:pPr algn="l">
               <a:defRPr sz="1275" b="0">
                 <a:solidFill>
@@ -9653,10 +9730,10 @@
                   <a:srgbClr val="172026"/>
                 </a:solidFill>
               </a:rPr>
-              <a:t>3. 更容易新增規則類型</a:t>
-            </a:r>
-          </a:p>
-          <a:p xmlns:a="http://schemas.openxmlformats.org/drawingml/2006/main">
+              <a:t>3. 新增規則時只補子類別步驟</a:t>
+            </a:r>
+          </a:p>
+          <a:p>
             <a:pPr algn="l">
               <a:defRPr sz="1275" b="0">
                 <a:solidFill>
@@ -9670,7 +9747,7 @@
                   <a:srgbClr val="172026"/>
                 </a:solidFill>
               </a:rPr>
-              <a:t>4. 未來可擴充為 StrategyFactory，支援多種回測策略</a:t>
+              <a:t>4. 和 Strategy 區隔：重點是「固定流程 + 延遲步驟」</a:t>
             </a:r>
           </a:p>
         </p:txBody>
@@ -9678,31 +9755,31 @@
       <p:sp>
         <p:nvSpPr>
           <p:cNvPr id="20" name="">
-            <a:extLst xmlns:a="http://schemas.openxmlformats.org/drawingml/2006/main">
-              <a:ext uri="{FF2B5EF4-FFF2-40B4-BE49-F238E27FC236}">
-                <a16:creationId xmlns:a16="http://schemas.microsoft.com/office/drawing/2014/main" id="{14989240-FEBF-40CC-8DFC-377D55A04A9D}"/>
-              </a:ext>
-            </a:extLst>
-          </p:cNvPr>
-          <p:cNvSpPr>
-            <a:spLocks xmlns:a="http://schemas.openxmlformats.org/drawingml/2006/main" noGrp="1"/>
-          </p:cNvSpPr>
-          <p:nvPr/>
-        </p:nvSpPr>
-        <p:spPr>
-          <a:xfrm xmlns:a="http://schemas.openxmlformats.org/drawingml/2006/main" rot="0">
+            <a:extLst>
+              <a:ext uri="{FF2B5EF4-FFF2-40B4-BE49-F238E27FC236}">
+                <ns2:creationId id="{14989240-FEBF-40CC-8DFC-377D55A04A9D}"/>
+              </a:ext>
+            </a:extLst>
+          </p:cNvPr>
+          <p:cNvSpPr>
+            <a:spLocks noGrp="1"/>
+          </p:cNvSpPr>
+          <p:nvPr/>
+        </p:nvSpPr>
+        <p:spPr>
+          <a:xfrm rot="0">
             <a:off x="4800600" y="4610100"/>
             <a:ext cx="1428750" cy="438150"/>
           </a:xfrm>
-          <a:prstGeom xmlns:a="http://schemas.openxmlformats.org/drawingml/2006/main" prst="roundRect">
+          <a:prstGeom prst="roundRect">
             <a:avLst>
               <a:gd name="adj" fmla="val 17391"/>
             </a:avLst>
           </a:prstGeom>
-          <a:solidFill xmlns:a="http://schemas.openxmlformats.org/drawingml/2006/main">
+          <a:solidFill>
             <a:srgbClr val="FBE5DF"/>
           </a:solidFill>
-          <a:ln xmlns:a="http://schemas.openxmlformats.org/drawingml/2006/main" w="10478">
+          <a:ln w="10478">
             <a:solidFill>
               <a:srgbClr val="23313B"/>
             </a:solidFill>
@@ -9713,31 +9790,31 @@
       <p:sp>
         <p:nvSpPr>
           <p:cNvPr id="21" name="">
-            <a:extLst xmlns:a="http://schemas.openxmlformats.org/drawingml/2006/main">
-              <a:ext uri="{FF2B5EF4-FFF2-40B4-BE49-F238E27FC236}">
-                <a16:creationId xmlns:a16="http://schemas.microsoft.com/office/drawing/2014/main" id="{F5355225-410F-4488-B797-0CF56A8C4C32}"/>
-              </a:ext>
-            </a:extLst>
-          </p:cNvPr>
-          <p:cNvSpPr>
-            <a:spLocks xmlns:a="http://schemas.openxmlformats.org/drawingml/2006/main" noGrp="1"/>
-          </p:cNvSpPr>
-          <p:nvPr/>
-        </p:nvSpPr>
-        <p:spPr>
-          <a:xfrm xmlns:a="http://schemas.openxmlformats.org/drawingml/2006/main" rot="0">
+            <a:extLst>
+              <a:ext uri="{FF2B5EF4-FFF2-40B4-BE49-F238E27FC236}">
+                <ns2:creationId id="{F5355225-410F-4488-B797-0CF56A8C4C32}"/>
+              </a:ext>
+            </a:extLst>
+          </p:cNvPr>
+          <p:cNvSpPr>
+            <a:spLocks noGrp="1"/>
+          </p:cNvSpPr>
+          <p:nvPr/>
+        </p:nvSpPr>
+        <p:spPr>
+          <a:xfrm rot="0">
             <a:off x="4800600" y="4724400"/>
             <a:ext cx="1428750" cy="171450"/>
           </a:xfrm>
-          <a:prstGeom xmlns:a="http://schemas.openxmlformats.org/drawingml/2006/main" prst="rect">
-            <a:avLst/>
-          </a:prstGeom>
-          <a:solidFill xmlns:a="http://schemas.openxmlformats.org/drawingml/2006/main">
+          <a:prstGeom prst="rect">
+            <a:avLst/>
+          </a:prstGeom>
+          <a:solidFill>
             <a:srgbClr val="000000">
               <a:alpha val="0"/>
             </a:srgbClr>
           </a:solidFill>
-          <a:ln xmlns:a="http://schemas.openxmlformats.org/drawingml/2006/main" w="0">
+          <a:ln w="0">
             <a:solidFill>
               <a:srgbClr val="000000">
                 <a:alpha val="0"/>
@@ -9747,9 +9824,9 @@
           </a:ln>
         </p:spPr>
         <p:txBody>
-          <a:bodyPr xmlns:a="http://schemas.openxmlformats.org/drawingml/2006/main" lIns="0" tIns="0" rIns="0" bIns="0" anchor="t"/>
-          <a:lstStyle xmlns:a="http://schemas.openxmlformats.org/drawingml/2006/main"/>
-          <a:p xmlns:a="http://schemas.openxmlformats.org/drawingml/2006/main">
+          <a:bodyPr lIns="0" tIns="0" rIns="0" bIns="0" anchor="t"/>
+          <a:lstStyle/>
+          <a:p>
             <a:pPr algn="ctr">
               <a:defRPr sz="1125" b="1">
                 <a:solidFill>
@@ -9763,7 +9840,7 @@
                   <a:srgbClr val="172026"/>
                 </a:solidFill>
               </a:rPr>
-              <a:t>DB 規則紀錄</a:t>
+              <a:t>AlertRule</a:t>
             </a:r>
           </a:p>
         </p:txBody>
@@ -9771,29 +9848,29 @@
       <p:sp>
         <p:nvSpPr>
           <p:cNvPr id="22" name="">
-            <a:extLst xmlns:a="http://schemas.openxmlformats.org/drawingml/2006/main">
-              <a:ext uri="{FF2B5EF4-FFF2-40B4-BE49-F238E27FC236}">
-                <a16:creationId xmlns:a16="http://schemas.microsoft.com/office/drawing/2014/main" id="{4A1B2ECF-6199-4F83-80C1-51043A56DA21}"/>
-              </a:ext>
-            </a:extLst>
-          </p:cNvPr>
-          <p:cNvSpPr>
-            <a:spLocks xmlns:a="http://schemas.openxmlformats.org/drawingml/2006/main" noGrp="1"/>
-          </p:cNvSpPr>
-          <p:nvPr/>
-        </p:nvSpPr>
-        <p:spPr>
-          <a:xfrm xmlns:a="http://schemas.openxmlformats.org/drawingml/2006/main" rot="0">
+            <a:extLst>
+              <a:ext uri="{FF2B5EF4-FFF2-40B4-BE49-F238E27FC236}">
+                <ns2:creationId id="{4A1B2ECF-6199-4F83-80C1-51043A56DA21}"/>
+              </a:ext>
+            </a:extLst>
+          </p:cNvPr>
+          <p:cNvSpPr>
+            <a:spLocks noGrp="1"/>
+          </p:cNvSpPr>
+          <p:nvPr/>
+        </p:nvSpPr>
+        <p:spPr>
+          <a:xfrm rot="0">
             <a:off x="6305550" y="4752975"/>
             <a:ext cx="704850" cy="133350"/>
           </a:xfrm>
-          <a:prstGeom xmlns:a="http://schemas.openxmlformats.org/drawingml/2006/main" prst="rightArrow">
-            <a:avLst/>
-          </a:prstGeom>
-          <a:solidFill xmlns:a="http://schemas.openxmlformats.org/drawingml/2006/main">
+          <a:prstGeom prst="rightArrow">
+            <a:avLst/>
+          </a:prstGeom>
+          <a:solidFill>
             <a:srgbClr val="172026"/>
           </a:solidFill>
-          <a:ln xmlns:a="http://schemas.openxmlformats.org/drawingml/2006/main" w="0">
+          <a:ln w="0">
             <a:solidFill>
               <a:srgbClr val="172026"/>
             </a:solidFill>
@@ -9804,31 +9881,31 @@
       <p:sp>
         <p:nvSpPr>
           <p:cNvPr id="23" name="">
-            <a:extLst xmlns:a="http://schemas.openxmlformats.org/drawingml/2006/main">
-              <a:ext uri="{FF2B5EF4-FFF2-40B4-BE49-F238E27FC236}">
-                <a16:creationId xmlns:a16="http://schemas.microsoft.com/office/drawing/2014/main" id="{FCF747A2-E8C1-4F50-AFE3-D2CDE1B8FE2D}"/>
-              </a:ext>
-            </a:extLst>
-          </p:cNvPr>
-          <p:cNvSpPr>
-            <a:spLocks xmlns:a="http://schemas.openxmlformats.org/drawingml/2006/main" noGrp="1"/>
-          </p:cNvSpPr>
-          <p:nvPr/>
-        </p:nvSpPr>
-        <p:spPr>
-          <a:xfrm xmlns:a="http://schemas.openxmlformats.org/drawingml/2006/main" rot="0">
+            <a:extLst>
+              <a:ext uri="{FF2B5EF4-FFF2-40B4-BE49-F238E27FC236}">
+                <ns2:creationId id="{FCF747A2-E8C1-4F50-AFE3-D2CDE1B8FE2D}"/>
+              </a:ext>
+            </a:extLst>
+          </p:cNvPr>
+          <p:cNvSpPr>
+            <a:spLocks noGrp="1"/>
+          </p:cNvSpPr>
+          <p:nvPr/>
+        </p:nvSpPr>
+        <p:spPr>
+          <a:xfrm rot="0">
             <a:off x="7067550" y="4514850"/>
             <a:ext cx="1485900" cy="628650"/>
           </a:xfrm>
-          <a:prstGeom xmlns:a="http://schemas.openxmlformats.org/drawingml/2006/main" prst="roundRect">
+          <a:prstGeom prst="roundRect">
             <a:avLst>
               <a:gd name="adj" fmla="val 12121"/>
             </a:avLst>
           </a:prstGeom>
-          <a:solidFill xmlns:a="http://schemas.openxmlformats.org/drawingml/2006/main">
+          <a:solidFill>
             <a:srgbClr val="DFF5EC"/>
           </a:solidFill>
-          <a:ln xmlns:a="http://schemas.openxmlformats.org/drawingml/2006/main" w="10478">
+          <a:ln w="10478">
             <a:solidFill>
               <a:srgbClr val="23313B"/>
             </a:solidFill>
@@ -9839,31 +9916,31 @@
       <p:sp>
         <p:nvSpPr>
           <p:cNvPr id="24" name="">
-            <a:extLst xmlns:a="http://schemas.openxmlformats.org/drawingml/2006/main">
-              <a:ext uri="{FF2B5EF4-FFF2-40B4-BE49-F238E27FC236}">
-                <a16:creationId xmlns:a16="http://schemas.microsoft.com/office/drawing/2014/main" id="{B4367873-1A2E-45BF-8CCC-6CE00E7073ED}"/>
-              </a:ext>
-            </a:extLst>
-          </p:cNvPr>
-          <p:cNvSpPr>
-            <a:spLocks xmlns:a="http://schemas.openxmlformats.org/drawingml/2006/main" noGrp="1"/>
-          </p:cNvSpPr>
-          <p:nvPr/>
-        </p:nvSpPr>
-        <p:spPr>
-          <a:xfrm xmlns:a="http://schemas.openxmlformats.org/drawingml/2006/main" rot="0">
+            <a:extLst>
+              <a:ext uri="{FF2B5EF4-FFF2-40B4-BE49-F238E27FC236}">
+                <ns2:creationId id="{B4367873-1A2E-45BF-8CCC-6CE00E7073ED}"/>
+              </a:ext>
+            </a:extLst>
+          </p:cNvPr>
+          <p:cNvSpPr>
+            <a:spLocks noGrp="1"/>
+          </p:cNvSpPr>
+          <p:nvPr/>
+        </p:nvSpPr>
+        <p:spPr>
+          <a:xfrm rot="0">
             <a:off x="7067550" y="4667250"/>
             <a:ext cx="1485900" cy="171450"/>
           </a:xfrm>
-          <a:prstGeom xmlns:a="http://schemas.openxmlformats.org/drawingml/2006/main" prst="rect">
-            <a:avLst/>
-          </a:prstGeom>
-          <a:solidFill xmlns:a="http://schemas.openxmlformats.org/drawingml/2006/main">
+          <a:prstGeom prst="rect">
+            <a:avLst/>
+          </a:prstGeom>
+          <a:solidFill>
             <a:srgbClr val="000000">
               <a:alpha val="0"/>
             </a:srgbClr>
           </a:solidFill>
-          <a:ln xmlns:a="http://schemas.openxmlformats.org/drawingml/2006/main" w="0">
+          <a:ln w="0">
             <a:solidFill>
               <a:srgbClr val="000000">
                 <a:alpha val="0"/>
@@ -9873,9 +9950,9 @@
           </a:ln>
         </p:spPr>
         <p:txBody>
-          <a:bodyPr xmlns:a="http://schemas.openxmlformats.org/drawingml/2006/main" lIns="0" tIns="0" rIns="0" bIns="0" anchor="t"/>
-          <a:lstStyle xmlns:a="http://schemas.openxmlformats.org/drawingml/2006/main"/>
-          <a:p xmlns:a="http://schemas.openxmlformats.org/drawingml/2006/main">
+          <a:bodyPr lIns="0" tIns="0" rIns="0" bIns="0" anchor="t"/>
+          <a:lstStyle/>
+          <a:p>
             <a:pPr algn="ctr">
               <a:defRPr sz="1125" b="1">
                 <a:solidFill>
@@ -9889,7 +9966,7 @@
                   <a:srgbClr val="172026"/>
                 </a:solidFill>
               </a:rPr>
-              <a:t>createAlertRule(...)</a:t>
+              <a:t>buildNotification()</a:t>
             </a:r>
           </a:p>
         </p:txBody>
@@ -9897,29 +9974,29 @@
       <p:sp>
         <p:nvSpPr>
           <p:cNvPr id="25" name="">
-            <a:extLst xmlns:a="http://schemas.openxmlformats.org/drawingml/2006/main">
-              <a:ext uri="{FF2B5EF4-FFF2-40B4-BE49-F238E27FC236}">
-                <a16:creationId xmlns:a16="http://schemas.microsoft.com/office/drawing/2014/main" id="{11944876-9532-4289-A0C1-F426D6AF216F}"/>
-              </a:ext>
-            </a:extLst>
-          </p:cNvPr>
-          <p:cNvSpPr>
-            <a:spLocks xmlns:a="http://schemas.openxmlformats.org/drawingml/2006/main" noGrp="1"/>
-          </p:cNvSpPr>
-          <p:nvPr/>
-        </p:nvSpPr>
-        <p:spPr>
-          <a:xfrm xmlns:a="http://schemas.openxmlformats.org/drawingml/2006/main" rot="0">
+            <a:extLst>
+              <a:ext uri="{FF2B5EF4-FFF2-40B4-BE49-F238E27FC236}">
+                <ns2:creationId id="{11944876-9532-4289-A0C1-F426D6AF216F}"/>
+              </a:ext>
+            </a:extLst>
+          </p:cNvPr>
+          <p:cNvSpPr>
+            <a:spLocks noGrp="1"/>
+          </p:cNvSpPr>
+          <p:nvPr/>
+        </p:nvSpPr>
+        <p:spPr>
+          <a:xfrm rot="0">
             <a:off x="8610600" y="4752975"/>
             <a:ext cx="704850" cy="133350"/>
           </a:xfrm>
-          <a:prstGeom xmlns:a="http://schemas.openxmlformats.org/drawingml/2006/main" prst="rightArrow">
-            <a:avLst/>
-          </a:prstGeom>
-          <a:solidFill xmlns:a="http://schemas.openxmlformats.org/drawingml/2006/main">
+          <a:prstGeom prst="rightArrow">
+            <a:avLst/>
+          </a:prstGeom>
+          <a:solidFill>
             <a:srgbClr val="172026"/>
           </a:solidFill>
-          <a:ln xmlns:a="http://schemas.openxmlformats.org/drawingml/2006/main" w="0">
+          <a:ln w="0">
             <a:solidFill>
               <a:srgbClr val="172026"/>
             </a:solidFill>
@@ -9930,31 +10007,31 @@
       <p:sp>
         <p:nvSpPr>
           <p:cNvPr id="26" name="">
-            <a:extLst xmlns:a="http://schemas.openxmlformats.org/drawingml/2006/main">
-              <a:ext uri="{FF2B5EF4-FFF2-40B4-BE49-F238E27FC236}">
-                <a16:creationId xmlns:a16="http://schemas.microsoft.com/office/drawing/2014/main" id="{38A06DDA-77D2-4356-A012-12F680FEFE8E}"/>
-              </a:ext>
-            </a:extLst>
-          </p:cNvPr>
-          <p:cNvSpPr>
-            <a:spLocks xmlns:a="http://schemas.openxmlformats.org/drawingml/2006/main" noGrp="1"/>
-          </p:cNvSpPr>
-          <p:nvPr/>
-        </p:nvSpPr>
-        <p:spPr>
-          <a:xfrm xmlns:a="http://schemas.openxmlformats.org/drawingml/2006/main" rot="0">
+            <a:extLst>
+              <a:ext uri="{FF2B5EF4-FFF2-40B4-BE49-F238E27FC236}">
+                <ns2:creationId id="{38A06DDA-77D2-4356-A012-12F680FEFE8E}"/>
+              </a:ext>
+            </a:extLst>
+          </p:cNvPr>
+          <p:cNvSpPr>
+            <a:spLocks noGrp="1"/>
+          </p:cNvSpPr>
+          <p:nvPr/>
+        </p:nvSpPr>
+        <p:spPr>
+          <a:xfrm rot="0">
             <a:off x="9391650" y="4400550"/>
             <a:ext cx="1733550" cy="381000"/>
           </a:xfrm>
-          <a:prstGeom xmlns:a="http://schemas.openxmlformats.org/drawingml/2006/main" prst="roundRect">
+          <a:prstGeom prst="roundRect">
             <a:avLst>
               <a:gd name="adj" fmla="val 20000"/>
             </a:avLst>
           </a:prstGeom>
-          <a:solidFill xmlns:a="http://schemas.openxmlformats.org/drawingml/2006/main">
+          <a:solidFill>
             <a:srgbClr val="FAEFD9"/>
           </a:solidFill>
-          <a:ln xmlns:a="http://schemas.openxmlformats.org/drawingml/2006/main" w="10478">
+          <a:ln w="10478">
             <a:solidFill>
               <a:srgbClr val="23313B"/>
             </a:solidFill>
@@ -9965,31 +10042,31 @@
       <p:sp>
         <p:nvSpPr>
           <p:cNvPr id="27" name="">
-            <a:extLst xmlns:a="http://schemas.openxmlformats.org/drawingml/2006/main">
-              <a:ext uri="{FF2B5EF4-FFF2-40B4-BE49-F238E27FC236}">
-                <a16:creationId xmlns:a16="http://schemas.microsoft.com/office/drawing/2014/main" id="{F22CE732-0B00-4BBB-82CC-EAF183885EF4}"/>
-              </a:ext>
-            </a:extLst>
-          </p:cNvPr>
-          <p:cNvSpPr>
-            <a:spLocks xmlns:a="http://schemas.openxmlformats.org/drawingml/2006/main" noGrp="1"/>
-          </p:cNvSpPr>
-          <p:nvPr/>
-        </p:nvSpPr>
-        <p:spPr>
-          <a:xfrm xmlns:a="http://schemas.openxmlformats.org/drawingml/2006/main" rot="0">
+            <a:extLst>
+              <a:ext uri="{FF2B5EF4-FFF2-40B4-BE49-F238E27FC236}">
+                <ns2:creationId id="{F22CE732-0B00-4BBB-82CC-EAF183885EF4}"/>
+              </a:ext>
+            </a:extLst>
+          </p:cNvPr>
+          <p:cNvSpPr>
+            <a:spLocks noGrp="1"/>
+          </p:cNvSpPr>
+          <p:nvPr/>
+        </p:nvSpPr>
+        <p:spPr>
+          <a:xfrm rot="0">
             <a:off x="9391650" y="4495800"/>
             <a:ext cx="1733550" cy="171450"/>
           </a:xfrm>
-          <a:prstGeom xmlns:a="http://schemas.openxmlformats.org/drawingml/2006/main" prst="rect">
-            <a:avLst/>
-          </a:prstGeom>
-          <a:solidFill xmlns:a="http://schemas.openxmlformats.org/drawingml/2006/main">
+          <a:prstGeom prst="rect">
+            <a:avLst/>
+          </a:prstGeom>
+          <a:solidFill>
             <a:srgbClr val="000000">
               <a:alpha val="0"/>
             </a:srgbClr>
           </a:solidFill>
-          <a:ln xmlns:a="http://schemas.openxmlformats.org/drawingml/2006/main" w="0">
+          <a:ln w="0">
             <a:solidFill>
               <a:srgbClr val="000000">
                 <a:alpha val="0"/>
@@ -9999,9 +10076,9 @@
           </a:ln>
         </p:spPr>
         <p:txBody>
-          <a:bodyPr xmlns:a="http://schemas.openxmlformats.org/drawingml/2006/main" lIns="0" tIns="0" rIns="0" bIns="0" anchor="t"/>
-          <a:lstStyle xmlns:a="http://schemas.openxmlformats.org/drawingml/2006/main"/>
-          <a:p xmlns:a="http://schemas.openxmlformats.org/drawingml/2006/main">
+          <a:bodyPr lIns="0" tIns="0" rIns="0" bIns="0" anchor="t"/>
+          <a:lstStyle/>
+          <a:p>
             <a:pPr algn="ctr">
               <a:defRPr sz="975" b="1">
                 <a:solidFill>
@@ -10015,7 +10092,7 @@
                   <a:srgbClr val="172026"/>
                 </a:solidFill>
               </a:rPr>
-              <a:t>PriceAboveAlertRule</a:t>
+              <a:t>PriceAboveRule</a:t>
             </a:r>
           </a:p>
         </p:txBody>
@@ -10023,31 +10100,31 @@
       <p:sp>
         <p:nvSpPr>
           <p:cNvPr id="28" name="">
-            <a:extLst xmlns:a="http://schemas.openxmlformats.org/drawingml/2006/main">
-              <a:ext uri="{FF2B5EF4-FFF2-40B4-BE49-F238E27FC236}">
-                <a16:creationId xmlns:a16="http://schemas.microsoft.com/office/drawing/2014/main" id="{F187C29D-BA7F-4ADC-ABE6-138C56C3675B}"/>
-              </a:ext>
-            </a:extLst>
-          </p:cNvPr>
-          <p:cNvSpPr>
-            <a:spLocks xmlns:a="http://schemas.openxmlformats.org/drawingml/2006/main" noGrp="1"/>
-          </p:cNvSpPr>
-          <p:nvPr/>
-        </p:nvSpPr>
-        <p:spPr>
-          <a:xfrm xmlns:a="http://schemas.openxmlformats.org/drawingml/2006/main" rot="0">
+            <a:extLst>
+              <a:ext uri="{FF2B5EF4-FFF2-40B4-BE49-F238E27FC236}">
+                <ns2:creationId id="{F187C29D-BA7F-4ADC-ABE6-138C56C3675B}"/>
+              </a:ext>
+            </a:extLst>
+          </p:cNvPr>
+          <p:cNvSpPr>
+            <a:spLocks noGrp="1"/>
+          </p:cNvSpPr>
+          <p:nvPr/>
+        </p:nvSpPr>
+        <p:spPr>
+          <a:xfrm rot="0">
             <a:off x="9391650" y="4876800"/>
             <a:ext cx="1733550" cy="381000"/>
           </a:xfrm>
-          <a:prstGeom xmlns:a="http://schemas.openxmlformats.org/drawingml/2006/main" prst="roundRect">
+          <a:prstGeom prst="roundRect">
             <a:avLst>
               <a:gd name="adj" fmla="val 20000"/>
             </a:avLst>
           </a:prstGeom>
-          <a:solidFill xmlns:a="http://schemas.openxmlformats.org/drawingml/2006/main">
+          <a:solidFill>
             <a:srgbClr val="E5EEFF"/>
           </a:solidFill>
-          <a:ln xmlns:a="http://schemas.openxmlformats.org/drawingml/2006/main" w="10478">
+          <a:ln w="10478">
             <a:solidFill>
               <a:srgbClr val="23313B"/>
             </a:solidFill>
@@ -10058,31 +10135,31 @@
       <p:sp>
         <p:nvSpPr>
           <p:cNvPr id="29" name="">
-            <a:extLst xmlns:a="http://schemas.openxmlformats.org/drawingml/2006/main">
-              <a:ext uri="{FF2B5EF4-FFF2-40B4-BE49-F238E27FC236}">
-                <a16:creationId xmlns:a16="http://schemas.microsoft.com/office/drawing/2014/main" id="{587BE118-3568-4149-B85D-648EFC08C8F3}"/>
-              </a:ext>
-            </a:extLst>
-          </p:cNvPr>
-          <p:cNvSpPr>
-            <a:spLocks xmlns:a="http://schemas.openxmlformats.org/drawingml/2006/main" noGrp="1"/>
-          </p:cNvSpPr>
-          <p:nvPr/>
-        </p:nvSpPr>
-        <p:spPr>
-          <a:xfrm xmlns:a="http://schemas.openxmlformats.org/drawingml/2006/main" rot="0">
+            <a:extLst>
+              <a:ext uri="{FF2B5EF4-FFF2-40B4-BE49-F238E27FC236}">
+                <ns2:creationId id="{587BE118-3568-4149-B85D-648EFC08C8F3}"/>
+              </a:ext>
+            </a:extLst>
+          </p:cNvPr>
+          <p:cNvSpPr>
+            <a:spLocks noGrp="1"/>
+          </p:cNvSpPr>
+          <p:nvPr/>
+        </p:nvSpPr>
+        <p:spPr>
+          <a:xfrm rot="0">
             <a:off x="9391650" y="4972050"/>
             <a:ext cx="1733550" cy="171450"/>
           </a:xfrm>
-          <a:prstGeom xmlns:a="http://schemas.openxmlformats.org/drawingml/2006/main" prst="rect">
-            <a:avLst/>
-          </a:prstGeom>
-          <a:solidFill xmlns:a="http://schemas.openxmlformats.org/drawingml/2006/main">
+          <a:prstGeom prst="rect">
+            <a:avLst/>
+          </a:prstGeom>
+          <a:solidFill>
             <a:srgbClr val="000000">
               <a:alpha val="0"/>
             </a:srgbClr>
           </a:solidFill>
-          <a:ln xmlns:a="http://schemas.openxmlformats.org/drawingml/2006/main" w="0">
+          <a:ln w="0">
             <a:solidFill>
               <a:srgbClr val="000000">
                 <a:alpha val="0"/>
@@ -10092,9 +10169,9 @@
           </a:ln>
         </p:spPr>
         <p:txBody>
-          <a:bodyPr xmlns:a="http://schemas.openxmlformats.org/drawingml/2006/main" lIns="0" tIns="0" rIns="0" bIns="0" anchor="t"/>
-          <a:lstStyle xmlns:a="http://schemas.openxmlformats.org/drawingml/2006/main"/>
-          <a:p xmlns:a="http://schemas.openxmlformats.org/drawingml/2006/main">
+          <a:bodyPr lIns="0" tIns="0" rIns="0" bIns="0" anchor="t"/>
+          <a:lstStyle/>
+          <a:p>
             <a:pPr algn="ctr">
               <a:defRPr sz="975" b="1">
                 <a:solidFill>
@@ -10108,7 +10185,7 @@
                   <a:srgbClr val="172026"/>
                 </a:solidFill>
               </a:rPr>
-              <a:t>PercentChangeUpAlertRule</a:t>
+              <a:t>PriceBelowRule</a:t>
             </a:r>
           </a:p>
         </p:txBody>
@@ -10116,31 +10193,31 @@
       <p:sp>
         <p:nvSpPr>
           <p:cNvPr id="30" name="">
-            <a:extLst xmlns:a="http://schemas.openxmlformats.org/drawingml/2006/main">
-              <a:ext uri="{FF2B5EF4-FFF2-40B4-BE49-F238E27FC236}">
-                <a16:creationId xmlns:a16="http://schemas.microsoft.com/office/drawing/2014/main" id="{E5CD213A-40E8-4BC9-BC14-15E59170B317}"/>
-              </a:ext>
-            </a:extLst>
-          </p:cNvPr>
-          <p:cNvSpPr>
-            <a:spLocks xmlns:a="http://schemas.openxmlformats.org/drawingml/2006/main" noGrp="1"/>
-          </p:cNvSpPr>
-          <p:nvPr/>
-        </p:nvSpPr>
-        <p:spPr>
-          <a:xfrm xmlns:a="http://schemas.openxmlformats.org/drawingml/2006/main" rot="0">
+            <a:extLst>
+              <a:ext uri="{FF2B5EF4-FFF2-40B4-BE49-F238E27FC236}">
+                <ns2:creationId id="{E5CD213A-40E8-4BC9-BC14-15E59170B317}"/>
+              </a:ext>
+            </a:extLst>
+          </p:cNvPr>
+          <p:cNvSpPr>
+            <a:spLocks noGrp="1"/>
+          </p:cNvSpPr>
+          <p:nvPr/>
+        </p:nvSpPr>
+        <p:spPr>
+          <a:xfrm rot="0">
             <a:off x="609600" y="6534150"/>
             <a:ext cx="9715500" cy="171450"/>
           </a:xfrm>
-          <a:prstGeom xmlns:a="http://schemas.openxmlformats.org/drawingml/2006/main" prst="rect">
-            <a:avLst/>
-          </a:prstGeom>
-          <a:solidFill xmlns:a="http://schemas.openxmlformats.org/drawingml/2006/main">
+          <a:prstGeom prst="rect">
+            <a:avLst/>
+          </a:prstGeom>
+          <a:solidFill>
             <a:srgbClr val="000000">
               <a:alpha val="0"/>
             </a:srgbClr>
           </a:solidFill>
-          <a:ln xmlns:a="http://schemas.openxmlformats.org/drawingml/2006/main" w="0">
+          <a:ln w="0">
             <a:solidFill>
               <a:srgbClr val="000000">
                 <a:alpha val="0"/>
@@ -10150,9 +10227,9 @@
           </a:ln>
         </p:spPr>
         <p:txBody>
-          <a:bodyPr xmlns:a="http://schemas.openxmlformats.org/drawingml/2006/main" lIns="0" tIns="0" rIns="0" bIns="0" anchor="t"/>
-          <a:lstStyle xmlns:a="http://schemas.openxmlformats.org/drawingml/2006/main"/>
-          <a:p xmlns:a="http://schemas.openxmlformats.org/drawingml/2006/main">
+          <a:bodyPr lIns="0" tIns="0" rIns="0" bIns="0" anchor="t"/>
+          <a:lstStyle/>
+          <a:p>
             <a:pPr algn="l">
               <a:defRPr sz="750" b="0">
                 <a:solidFill>
@@ -10174,7 +10251,7 @@
     </p:spTree>
     <p:extLst>
       <p:ext uri="{BB962C8B-B14F-4D97-AF65-F5344CB8AC3E}">
-        <p14:creationId xmlns:p14="http://schemas.microsoft.com/office/powerpoint/2010/main" val="741896479"/>
+        <ns3:creationId val="741896479"/>
       </p:ext>
     </p:extLst>
   </p:cSld>

</xml_diff>